<commit_message>
fix design for slam and vla.
</commit_message>
<xml_diff>
--- a/images/arch.pptx
+++ b/images/arch.pptx
@@ -288,7 +288,7 @@
           <a:p>
             <a:fld id="{9E50BDAC-40CF-4CAB-92B6-8882156A02C4}" type="datetimeFigureOut">
               <a:rPr lang="zh-CN" altLang="en-US" smtClean="0"/>
-              <a:t>2026/5/23</a:t>
+              <a:t>2026/10/25</a:t>
             </a:fld>
             <a:endParaRPr lang="zh-CN" altLang="en-US"/>
           </a:p>
@@ -458,7 +458,7 @@
           <a:p>
             <a:fld id="{9E50BDAC-40CF-4CAB-92B6-8882156A02C4}" type="datetimeFigureOut">
               <a:rPr lang="zh-CN" altLang="en-US" smtClean="0"/>
-              <a:t>2026/5/23</a:t>
+              <a:t>2026/10/25</a:t>
             </a:fld>
             <a:endParaRPr lang="zh-CN" altLang="en-US"/>
           </a:p>
@@ -638,7 +638,7 @@
           <a:p>
             <a:fld id="{9E50BDAC-40CF-4CAB-92B6-8882156A02C4}" type="datetimeFigureOut">
               <a:rPr lang="zh-CN" altLang="en-US" smtClean="0"/>
-              <a:t>2026/5/23</a:t>
+              <a:t>2026/10/25</a:t>
             </a:fld>
             <a:endParaRPr lang="zh-CN" altLang="en-US"/>
           </a:p>
@@ -808,7 +808,7 @@
           <a:p>
             <a:fld id="{9E50BDAC-40CF-4CAB-92B6-8882156A02C4}" type="datetimeFigureOut">
               <a:rPr lang="zh-CN" altLang="en-US" smtClean="0"/>
-              <a:t>2026/5/23</a:t>
+              <a:t>2026/10/25</a:t>
             </a:fld>
             <a:endParaRPr lang="zh-CN" altLang="en-US"/>
           </a:p>
@@ -1054,7 +1054,7 @@
           <a:p>
             <a:fld id="{9E50BDAC-40CF-4CAB-92B6-8882156A02C4}" type="datetimeFigureOut">
               <a:rPr lang="zh-CN" altLang="en-US" smtClean="0"/>
-              <a:t>2026/5/23</a:t>
+              <a:t>2026/10/25</a:t>
             </a:fld>
             <a:endParaRPr lang="zh-CN" altLang="en-US"/>
           </a:p>
@@ -1342,7 +1342,7 @@
           <a:p>
             <a:fld id="{9E50BDAC-40CF-4CAB-92B6-8882156A02C4}" type="datetimeFigureOut">
               <a:rPr lang="zh-CN" altLang="en-US" smtClean="0"/>
-              <a:t>2026/5/23</a:t>
+              <a:t>2026/10/25</a:t>
             </a:fld>
             <a:endParaRPr lang="zh-CN" altLang="en-US"/>
           </a:p>
@@ -1764,7 +1764,7 @@
           <a:p>
             <a:fld id="{9E50BDAC-40CF-4CAB-92B6-8882156A02C4}" type="datetimeFigureOut">
               <a:rPr lang="zh-CN" altLang="en-US" smtClean="0"/>
-              <a:t>2026/5/23</a:t>
+              <a:t>2026/10/25</a:t>
             </a:fld>
             <a:endParaRPr lang="zh-CN" altLang="en-US"/>
           </a:p>
@@ -1882,7 +1882,7 @@
           <a:p>
             <a:fld id="{9E50BDAC-40CF-4CAB-92B6-8882156A02C4}" type="datetimeFigureOut">
               <a:rPr lang="zh-CN" altLang="en-US" smtClean="0"/>
-              <a:t>2026/5/23</a:t>
+              <a:t>2026/10/25</a:t>
             </a:fld>
             <a:endParaRPr lang="zh-CN" altLang="en-US"/>
           </a:p>
@@ -1977,7 +1977,7 @@
           <a:p>
             <a:fld id="{9E50BDAC-40CF-4CAB-92B6-8882156A02C4}" type="datetimeFigureOut">
               <a:rPr lang="zh-CN" altLang="en-US" smtClean="0"/>
-              <a:t>2026/5/23</a:t>
+              <a:t>2026/10/25</a:t>
             </a:fld>
             <a:endParaRPr lang="zh-CN" altLang="en-US"/>
           </a:p>
@@ -2254,7 +2254,7 @@
           <a:p>
             <a:fld id="{9E50BDAC-40CF-4CAB-92B6-8882156A02C4}" type="datetimeFigureOut">
               <a:rPr lang="zh-CN" altLang="en-US" smtClean="0"/>
-              <a:t>2026/5/23</a:t>
+              <a:t>2026/10/25</a:t>
             </a:fld>
             <a:endParaRPr lang="zh-CN" altLang="en-US"/>
           </a:p>
@@ -2507,7 +2507,7 @@
           <a:p>
             <a:fld id="{9E50BDAC-40CF-4CAB-92B6-8882156A02C4}" type="datetimeFigureOut">
               <a:rPr lang="zh-CN" altLang="en-US" smtClean="0"/>
-              <a:t>2026/5/23</a:t>
+              <a:t>2026/10/25</a:t>
             </a:fld>
             <a:endParaRPr lang="zh-CN" altLang="en-US"/>
           </a:p>
@@ -2720,7 +2720,7 @@
           <a:p>
             <a:fld id="{9E50BDAC-40CF-4CAB-92B6-8882156A02C4}" type="datetimeFigureOut">
               <a:rPr lang="zh-CN" altLang="en-US" smtClean="0"/>
-              <a:t>2026/5/23</a:t>
+              <a:t>2026/10/25</a:t>
             </a:fld>
             <a:endParaRPr lang="zh-CN" altLang="en-US"/>
           </a:p>
@@ -3118,7 +3118,7 @@
         </p:blipFill>
         <p:spPr bwMode="auto">
           <a:xfrm rot="16200000">
-            <a:off x="1379223" y="1113749"/>
+            <a:off x="1530582" y="542970"/>
             <a:ext cx="1418169" cy="2736304"/>
           </a:xfrm>
           <a:prstGeom prst="rect">
@@ -3246,7 +3246,7 @@
           <p:nvPr/>
         </p:nvPicPr>
         <p:blipFill>
-          <a:blip r:embed="rId3">
+          <a:blip r:embed="rId3" cstate="print">
             <a:extLst>
               <a:ext uri="{28A0092B-C50C-407E-A947-70E740481C1C}">
                 <a14:useLocalDpi xmlns:a14="http://schemas.microsoft.com/office/drawing/2010/main" val="0"/>
@@ -3260,8 +3260,8 @@
         </p:blipFill>
         <p:spPr bwMode="auto">
           <a:xfrm flipH="1">
-            <a:off x="40078" y="1859613"/>
-            <a:ext cx="608069" cy="985072"/>
+            <a:off x="263445" y="1306209"/>
+            <a:ext cx="608069" cy="590857"/>
           </a:xfrm>
           <a:prstGeom prst="rect">
             <a:avLst/>
@@ -3310,7 +3310,7 @@
           <p:nvPr/>
         </p:nvPicPr>
         <p:blipFill>
-          <a:blip r:embed="rId4">
+          <a:blip r:embed="rId4" cstate="print">
             <a:extLst>
               <a:ext uri="{28A0092B-C50C-407E-A947-70E740481C1C}">
                 <a14:useLocalDpi xmlns:a14="http://schemas.microsoft.com/office/drawing/2010/main" val="0"/>
@@ -3323,9 +3323,9 @@
           </a:stretch>
         </p:blipFill>
         <p:spPr bwMode="auto">
-          <a:xfrm>
-            <a:off x="1230512" y="3190986"/>
-            <a:ext cx="583845" cy="864096"/>
+          <a:xfrm rot="5400000">
+            <a:off x="296095" y="1975491"/>
+            <a:ext cx="495442" cy="507719"/>
           </a:xfrm>
           <a:prstGeom prst="rect">
             <a:avLst/>
@@ -3387,9 +3387,9 @@
           </a:stretch>
         </p:blipFill>
         <p:spPr bwMode="auto">
-          <a:xfrm rot="5400000">
-            <a:off x="3708153" y="2266657"/>
-            <a:ext cx="418582" cy="460971"/>
+          <a:xfrm>
+            <a:off x="3816499" y="2515130"/>
+            <a:ext cx="676840" cy="745382"/>
           </a:xfrm>
           <a:prstGeom prst="rect">
             <a:avLst/>
@@ -3437,7 +3437,7 @@
         </p:nvSpPr>
         <p:spPr>
           <a:xfrm>
-            <a:off x="4420928" y="1336625"/>
+            <a:off x="4816248" y="1618878"/>
             <a:ext cx="5444244" cy="2786322"/>
           </a:xfrm>
           <a:prstGeom prst="rect">
@@ -3493,7 +3493,7 @@
         </p:nvSpPr>
         <p:spPr>
           <a:xfrm>
-            <a:off x="4570205" y="1927477"/>
+            <a:off x="4965525" y="2209730"/>
             <a:ext cx="1543490" cy="1857420"/>
           </a:xfrm>
           <a:prstGeom prst="rect">
@@ -3565,7 +3565,7 @@
         </p:blipFill>
         <p:spPr bwMode="auto">
           <a:xfrm>
-            <a:off x="4707162" y="2225731"/>
+            <a:off x="5102482" y="2507984"/>
             <a:ext cx="493723" cy="407038"/>
           </a:xfrm>
           <a:prstGeom prst="rect">
@@ -3614,7 +3614,7 @@
         </p:nvSpPr>
         <p:spPr>
           <a:xfrm>
-            <a:off x="4707162" y="2848793"/>
+            <a:off x="5102482" y="3131046"/>
             <a:ext cx="1269574" cy="238014"/>
           </a:xfrm>
           <a:prstGeom prst="rect">
@@ -3659,7 +3659,17 @@
                 <a:latin typeface="微软雅黑" panose="020B0503020204020204" pitchFamily="34" charset="-122"/>
                 <a:ea typeface="微软雅黑" panose="020B0503020204020204" pitchFamily="34" charset="-122"/>
               </a:rPr>
-              <a:t>Ps2 web server</a:t>
+              <a:t>PS2 </a:t>
+            </a:r>
+            <a:r>
+              <a:rPr lang="en-US" altLang="zh-CN" sz="1100" dirty="0" smtClean="0">
+                <a:solidFill>
+                  <a:schemeClr val="tx1"/>
+                </a:solidFill>
+                <a:latin typeface="微软雅黑" panose="020B0503020204020204" pitchFamily="34" charset="-122"/>
+                <a:ea typeface="微软雅黑" panose="020B0503020204020204" pitchFamily="34" charset="-122"/>
+              </a:rPr>
+              <a:t>web server</a:t>
             </a:r>
             <a:endParaRPr lang="zh-CN" altLang="en-US" sz="1100" dirty="0">
               <a:solidFill>
@@ -3679,7 +3689,7 @@
         </p:nvSpPr>
         <p:spPr>
           <a:xfrm>
-            <a:off x="4707162" y="3139844"/>
+            <a:off x="5102482" y="3422097"/>
             <a:ext cx="1269574" cy="238014"/>
           </a:xfrm>
           <a:prstGeom prst="rect">
@@ -3717,16 +3727,16 @@
           <a:p>
             <a:pPr algn="ctr"/>
             <a:r>
-              <a:rPr lang="en-US" altLang="zh-CN" sz="1100" dirty="0" smtClean="0">
+              <a:rPr lang="en-US" altLang="zh-CN" sz="900" dirty="0" smtClean="0">
                 <a:solidFill>
                   <a:schemeClr val="tx1"/>
                 </a:solidFill>
                 <a:latin typeface="微软雅黑" panose="020B0503020204020204" pitchFamily="34" charset="-122"/>
                 <a:ea typeface="微软雅黑" panose="020B0503020204020204" pitchFamily="34" charset="-122"/>
               </a:rPr>
-              <a:t>VLA Infer</a:t>
-            </a:r>
-            <a:endParaRPr lang="zh-CN" altLang="en-US" sz="1100" dirty="0">
+              <a:t>Command Receiver</a:t>
+            </a:r>
+            <a:endParaRPr lang="zh-CN" altLang="en-US" sz="900" dirty="0">
               <a:solidFill>
                 <a:schemeClr val="tx1"/>
               </a:solidFill>
@@ -3744,7 +3754,7 @@
         </p:nvSpPr>
         <p:spPr>
           <a:xfrm>
-            <a:off x="6536886" y="1927477"/>
+            <a:off x="6932206" y="2209730"/>
             <a:ext cx="3172389" cy="1563837"/>
           </a:xfrm>
           <a:prstGeom prst="rect">
@@ -3801,7 +3811,7 @@
         </p:nvSpPr>
         <p:spPr>
           <a:xfrm>
-            <a:off x="4707162" y="3438764"/>
+            <a:off x="5102482" y="3721017"/>
             <a:ext cx="1269574" cy="238014"/>
           </a:xfrm>
           <a:prstGeom prst="rect">
@@ -3881,7 +3891,7 @@
         </p:blipFill>
         <p:spPr bwMode="auto">
           <a:xfrm>
-            <a:off x="4261917" y="3712889"/>
+            <a:off x="4657237" y="3995142"/>
             <a:ext cx="447490" cy="357012"/>
           </a:xfrm>
           <a:prstGeom prst="rect">
@@ -3933,7 +3943,7 @@
         </p:nvCxnSpPr>
         <p:spPr>
           <a:xfrm rot="5400000" flipH="1" flipV="1">
-            <a:off x="4518852" y="3524581"/>
+            <a:off x="4914172" y="3806834"/>
             <a:ext cx="155118" cy="221502"/>
           </a:xfrm>
           <a:prstGeom prst="bentConnector2">
@@ -3960,16 +3970,154 @@
           </a:fontRef>
         </p:style>
       </p:cxnSp>
+      <p:sp>
+        <p:nvSpPr>
+          <p:cNvPr id="13" name="TextBox 12"/>
+          <p:cNvSpPr txBox="1"/>
+          <p:nvPr/>
+        </p:nvSpPr>
+        <p:spPr>
+          <a:xfrm>
+            <a:off x="5163910" y="2861966"/>
+            <a:ext cx="349851" cy="246221"/>
+          </a:xfrm>
+          <a:prstGeom prst="rect">
+            <a:avLst/>
+          </a:prstGeom>
+          <a:noFill/>
+        </p:spPr>
+        <p:txBody>
+          <a:bodyPr wrap="none" rtlCol="0">
+            <a:spAutoFit/>
+          </a:bodyPr>
+          <a:lstStyle/>
+          <a:p>
+            <a:r>
+              <a:rPr lang="en-US" altLang="zh-CN" sz="1000" dirty="0" smtClean="0"/>
+              <a:t>WIFI</a:t>
+            </a:r>
+            <a:endParaRPr lang="zh-CN" altLang="en-US" sz="1000" dirty="0"/>
+          </a:p>
+        </p:txBody>
+      </p:sp>
+      <p:sp>
+        <p:nvSpPr>
+          <p:cNvPr id="27" name="TextBox 26"/>
+          <p:cNvSpPr txBox="1"/>
+          <p:nvPr/>
+        </p:nvSpPr>
+        <p:spPr>
+          <a:xfrm>
+            <a:off x="5655309" y="2861965"/>
+            <a:ext cx="867545" cy="246221"/>
+          </a:xfrm>
+          <a:prstGeom prst="rect">
+            <a:avLst/>
+          </a:prstGeom>
+          <a:noFill/>
+        </p:spPr>
+        <p:txBody>
+          <a:bodyPr wrap="none" rtlCol="0">
+            <a:spAutoFit/>
+          </a:bodyPr>
+          <a:lstStyle/>
+          <a:p>
+            <a:r>
+              <a:rPr lang="en-US" altLang="zh-CN" sz="1000" dirty="0" smtClean="0"/>
+              <a:t>Main Control</a:t>
+            </a:r>
+            <a:endParaRPr lang="zh-CN" altLang="en-US" sz="1000" dirty="0"/>
+          </a:p>
+        </p:txBody>
+      </p:sp>
+      <p:sp>
+        <p:nvSpPr>
+          <p:cNvPr id="28" name="矩形 27"/>
+          <p:cNvSpPr/>
+          <p:nvPr/>
+        </p:nvSpPr>
+        <p:spPr>
+          <a:xfrm>
+            <a:off x="7252436" y="2775149"/>
+            <a:ext cx="895680" cy="383969"/>
+          </a:xfrm>
+          <a:prstGeom prst="rect">
+            <a:avLst/>
+          </a:prstGeom>
+          <a:noFill/>
+          <a:ln w="6350">
+            <a:solidFill>
+              <a:schemeClr val="accent3">
+                <a:lumMod val="40000"/>
+                <a:lumOff val="60000"/>
+              </a:schemeClr>
+            </a:solidFill>
+          </a:ln>
+        </p:spPr>
+        <p:style>
+          <a:lnRef idx="2">
+            <a:schemeClr val="accent1">
+              <a:shade val="50000"/>
+            </a:schemeClr>
+          </a:lnRef>
+          <a:fillRef idx="1">
+            <a:schemeClr val="accent1"/>
+          </a:fillRef>
+          <a:effectRef idx="0">
+            <a:schemeClr val="accent1"/>
+          </a:effectRef>
+          <a:fontRef idx="minor">
+            <a:schemeClr val="lt1"/>
+          </a:fontRef>
+        </p:style>
+        <p:txBody>
+          <a:bodyPr rtlCol="0" anchor="ctr"/>
+          <a:lstStyle/>
+          <a:p>
+            <a:pPr algn="ctr"/>
+            <a:r>
+              <a:rPr lang="en-US" altLang="zh-CN" sz="1050" dirty="0" smtClean="0">
+                <a:solidFill>
+                  <a:schemeClr val="tx1"/>
+                </a:solidFill>
+                <a:latin typeface="微软雅黑" panose="020B0503020204020204" pitchFamily="34" charset="-122"/>
+                <a:ea typeface="微软雅黑" panose="020B0503020204020204" pitchFamily="34" charset="-122"/>
+              </a:rPr>
+              <a:t>Command</a:t>
+            </a:r>
+          </a:p>
+          <a:p>
+            <a:pPr algn="ctr"/>
+            <a:r>
+              <a:rPr lang="en-US" altLang="zh-CN" sz="1050" dirty="0" smtClean="0">
+                <a:solidFill>
+                  <a:schemeClr val="tx1"/>
+                </a:solidFill>
+                <a:latin typeface="微软雅黑" panose="020B0503020204020204" pitchFamily="34" charset="-122"/>
+                <a:ea typeface="微软雅黑" panose="020B0503020204020204" pitchFamily="34" charset="-122"/>
+              </a:rPr>
+              <a:t>Receiver</a:t>
+            </a:r>
+            <a:endParaRPr lang="zh-CN" altLang="en-US" sz="1050" dirty="0">
+              <a:solidFill>
+                <a:schemeClr val="tx1"/>
+              </a:solidFill>
+              <a:latin typeface="微软雅黑" panose="020B0503020204020204" pitchFamily="34" charset="-122"/>
+              <a:ea typeface="微软雅黑" panose="020B0503020204020204" pitchFamily="34" charset="-122"/>
+            </a:endParaRPr>
+          </a:p>
+        </p:txBody>
+      </p:sp>
       <p:pic>
         <p:nvPicPr>
-          <p:cNvPr id="1041" name="Picture 17"/>
+          <p:cNvPr id="1043" name="Picture 19"/>
           <p:cNvPicPr>
             <a:picLocks noChangeAspect="1" noChangeArrowheads="1"/>
           </p:cNvPicPr>
           <p:nvPr/>
         </p:nvPicPr>
         <p:blipFill>
-          <a:blip r:embed="rId8">
+          <a:blip r:embed="rId8" cstate="print">
             <a:extLst>
               <a:ext uri="{28A0092B-C50C-407E-A947-70E740481C1C}">
                 <a14:useLocalDpi xmlns:a14="http://schemas.microsoft.com/office/drawing/2010/main" val="0"/>
@@ -3983,8 +4131,8 @@
         </p:blipFill>
         <p:spPr bwMode="auto">
           <a:xfrm>
-            <a:off x="5478908" y="2225730"/>
-            <a:ext cx="448531" cy="407039"/>
+            <a:off x="4701618" y="3335244"/>
+            <a:ext cx="358725" cy="371866"/>
           </a:xfrm>
           <a:prstGeom prst="rect">
             <a:avLst/>
@@ -4024,208 +4172,6 @@
           </a:extLst>
         </p:spPr>
       </p:pic>
-      <p:sp>
-        <p:nvSpPr>
-          <p:cNvPr id="13" name="TextBox 12"/>
-          <p:cNvSpPr txBox="1"/>
-          <p:nvPr/>
-        </p:nvSpPr>
-        <p:spPr>
-          <a:xfrm>
-            <a:off x="4768590" y="2579713"/>
-            <a:ext cx="349851" cy="246221"/>
-          </a:xfrm>
-          <a:prstGeom prst="rect">
-            <a:avLst/>
-          </a:prstGeom>
-          <a:noFill/>
-        </p:spPr>
-        <p:txBody>
-          <a:bodyPr wrap="none" rtlCol="0">
-            <a:spAutoFit/>
-          </a:bodyPr>
-          <a:lstStyle/>
-          <a:p>
-            <a:r>
-              <a:rPr lang="en-US" altLang="zh-CN" sz="1000" dirty="0" smtClean="0"/>
-              <a:t>WIFI</a:t>
-            </a:r>
-            <a:endParaRPr lang="zh-CN" altLang="en-US" sz="1000" dirty="0"/>
-          </a:p>
-        </p:txBody>
-      </p:sp>
-      <p:sp>
-        <p:nvSpPr>
-          <p:cNvPr id="27" name="TextBox 26"/>
-          <p:cNvSpPr txBox="1"/>
-          <p:nvPr/>
-        </p:nvSpPr>
-        <p:spPr>
-          <a:xfrm>
-            <a:off x="5524949" y="2579713"/>
-            <a:ext cx="319280" cy="246221"/>
-          </a:xfrm>
-          <a:prstGeom prst="rect">
-            <a:avLst/>
-          </a:prstGeom>
-          <a:noFill/>
-        </p:spPr>
-        <p:txBody>
-          <a:bodyPr wrap="none" rtlCol="0">
-            <a:spAutoFit/>
-          </a:bodyPr>
-          <a:lstStyle/>
-          <a:p>
-            <a:r>
-              <a:rPr lang="en-US" altLang="zh-CN" sz="1000" dirty="0" smtClean="0"/>
-              <a:t>VLA</a:t>
-            </a:r>
-            <a:endParaRPr lang="zh-CN" altLang="en-US" sz="1000" dirty="0"/>
-          </a:p>
-        </p:txBody>
-      </p:sp>
-      <p:sp>
-        <p:nvSpPr>
-          <p:cNvPr id="28" name="矩形 27"/>
-          <p:cNvSpPr/>
-          <p:nvPr/>
-        </p:nvSpPr>
-        <p:spPr>
-          <a:xfrm>
-            <a:off x="6857116" y="2492896"/>
-            <a:ext cx="895680" cy="383969"/>
-          </a:xfrm>
-          <a:prstGeom prst="rect">
-            <a:avLst/>
-          </a:prstGeom>
-          <a:noFill/>
-          <a:ln w="6350">
-            <a:solidFill>
-              <a:schemeClr val="accent3">
-                <a:lumMod val="40000"/>
-                <a:lumOff val="60000"/>
-              </a:schemeClr>
-            </a:solidFill>
-          </a:ln>
-        </p:spPr>
-        <p:style>
-          <a:lnRef idx="2">
-            <a:schemeClr val="accent1">
-              <a:shade val="50000"/>
-            </a:schemeClr>
-          </a:lnRef>
-          <a:fillRef idx="1">
-            <a:schemeClr val="accent1"/>
-          </a:fillRef>
-          <a:effectRef idx="0">
-            <a:schemeClr val="accent1"/>
-          </a:effectRef>
-          <a:fontRef idx="minor">
-            <a:schemeClr val="lt1"/>
-          </a:fontRef>
-        </p:style>
-        <p:txBody>
-          <a:bodyPr rtlCol="0" anchor="ctr"/>
-          <a:lstStyle/>
-          <a:p>
-            <a:pPr algn="ctr"/>
-            <a:r>
-              <a:rPr lang="en-US" altLang="zh-CN" sz="1050" dirty="0" smtClean="0">
-                <a:solidFill>
-                  <a:schemeClr val="tx1"/>
-                </a:solidFill>
-                <a:latin typeface="微软雅黑" panose="020B0503020204020204" pitchFamily="34" charset="-122"/>
-                <a:ea typeface="微软雅黑" panose="020B0503020204020204" pitchFamily="34" charset="-122"/>
-              </a:rPr>
-              <a:t>Command</a:t>
-            </a:r>
-          </a:p>
-          <a:p>
-            <a:pPr algn="ctr"/>
-            <a:r>
-              <a:rPr lang="en-US" altLang="zh-CN" sz="1050" dirty="0" smtClean="0">
-                <a:solidFill>
-                  <a:schemeClr val="tx1"/>
-                </a:solidFill>
-                <a:latin typeface="微软雅黑" panose="020B0503020204020204" pitchFamily="34" charset="-122"/>
-                <a:ea typeface="微软雅黑" panose="020B0503020204020204" pitchFamily="34" charset="-122"/>
-              </a:rPr>
-              <a:t>Receiver</a:t>
-            </a:r>
-            <a:endParaRPr lang="zh-CN" altLang="en-US" sz="1050" dirty="0">
-              <a:solidFill>
-                <a:schemeClr val="tx1"/>
-              </a:solidFill>
-              <a:latin typeface="微软雅黑" panose="020B0503020204020204" pitchFamily="34" charset="-122"/>
-              <a:ea typeface="微软雅黑" panose="020B0503020204020204" pitchFamily="34" charset="-122"/>
-            </a:endParaRPr>
-          </a:p>
-        </p:txBody>
-      </p:sp>
-      <p:pic>
-        <p:nvPicPr>
-          <p:cNvPr id="1043" name="Picture 19"/>
-          <p:cNvPicPr>
-            <a:picLocks noChangeAspect="1" noChangeArrowheads="1"/>
-          </p:cNvPicPr>
-          <p:nvPr/>
-        </p:nvPicPr>
-        <p:blipFill>
-          <a:blip r:embed="rId9" cstate="print">
-            <a:extLst>
-              <a:ext uri="{28A0092B-C50C-407E-A947-70E740481C1C}">
-                <a14:useLocalDpi xmlns:a14="http://schemas.microsoft.com/office/drawing/2010/main" val="0"/>
-              </a:ext>
-            </a:extLst>
-          </a:blip>
-          <a:srcRect/>
-          <a:stretch>
-            <a:fillRect/>
-          </a:stretch>
-        </p:blipFill>
-        <p:spPr bwMode="auto">
-          <a:xfrm>
-            <a:off x="4306298" y="3052991"/>
-            <a:ext cx="358725" cy="371866"/>
-          </a:xfrm>
-          <a:prstGeom prst="rect">
-            <a:avLst/>
-          </a:prstGeom>
-          <a:noFill/>
-          <a:ln>
-            <a:noFill/>
-          </a:ln>
-          <a:effectLst/>
-          <a:extLst>
-            <a:ext uri="{909E8E84-426E-40DD-AFC4-6F175D3DCCD1}">
-              <a14:hiddenFill xmlns:a14="http://schemas.microsoft.com/office/drawing/2010/main">
-                <a:solidFill>
-                  <a:schemeClr val="accent1"/>
-                </a:solidFill>
-              </a14:hiddenFill>
-            </a:ext>
-            <a:ext uri="{91240B29-F687-4F45-9708-019B960494DF}">
-              <a14:hiddenLine xmlns:a14="http://schemas.microsoft.com/office/drawing/2010/main" w="9525">
-                <a:solidFill>
-                  <a:schemeClr val="tx1"/>
-                </a:solidFill>
-                <a:miter lim="800000"/>
-                <a:headEnd/>
-                <a:tailEnd/>
-              </a14:hiddenLine>
-            </a:ext>
-            <a:ext uri="{AF507438-7753-43E0-B8FC-AC1667EBCBE1}">
-              <a14:hiddenEffects xmlns:a14="http://schemas.microsoft.com/office/drawing/2010/main">
-                <a:effectLst>
-                  <a:outerShdw dist="35921" dir="2700000" algn="ctr" rotWithShape="0">
-                    <a:schemeClr val="bg2"/>
-                  </a:outerShdw>
-                </a:effectLst>
-              </a14:hiddenEffects>
-            </a:ext>
-          </a:extLst>
-        </p:spPr>
-      </p:pic>
       <p:cxnSp>
         <p:nvCxnSpPr>
           <p:cNvPr id="37" name="肘形连接符 36"/>
@@ -4237,7 +4183,7 @@
         </p:nvCxnSpPr>
         <p:spPr>
           <a:xfrm rot="16200000" flipH="1">
-            <a:off x="4529955" y="3380563"/>
+            <a:off x="4925275" y="3662816"/>
             <a:ext cx="132914" cy="221503"/>
           </a:xfrm>
           <a:prstGeom prst="bentConnector2">
@@ -4272,7 +4218,7 @@
         </p:nvSpPr>
         <p:spPr>
           <a:xfrm>
-            <a:off x="6009950" y="2183514"/>
+            <a:off x="6405270" y="2465767"/>
             <a:ext cx="207490" cy="205029"/>
           </a:xfrm>
           <a:prstGeom prst="rect">
@@ -4316,7 +4262,7 @@
         </p:nvSpPr>
         <p:spPr>
           <a:xfrm>
-            <a:off x="6412955" y="2183514"/>
+            <a:off x="6808275" y="2465767"/>
             <a:ext cx="207490" cy="205029"/>
           </a:xfrm>
           <a:prstGeom prst="rect">
@@ -4363,7 +4309,7 @@
         </p:nvCxnSpPr>
         <p:spPr>
           <a:xfrm>
-            <a:off x="6217439" y="2286028"/>
+            <a:off x="6612759" y="2568281"/>
             <a:ext cx="195516" cy="0"/>
           </a:xfrm>
           <a:prstGeom prst="line">
@@ -4393,7 +4339,7 @@
         </p:nvGrpSpPr>
         <p:grpSpPr>
           <a:xfrm>
-            <a:off x="7872625" y="2554323"/>
+            <a:off x="8267945" y="2836576"/>
             <a:ext cx="593705" cy="261242"/>
             <a:chOff x="7350247" y="2758068"/>
             <a:chExt cx="606129" cy="261242"/>
@@ -4491,7 +4437,7 @@
         </p:nvSpPr>
         <p:spPr>
           <a:xfrm>
-            <a:off x="8661683" y="2492896"/>
+            <a:off x="9057003" y="2775149"/>
             <a:ext cx="915456" cy="383969"/>
           </a:xfrm>
           <a:prstGeom prst="rect">
@@ -4572,7 +4518,7 @@
         </p:nvCxnSpPr>
         <p:spPr>
           <a:xfrm>
-            <a:off x="8466330" y="2684760"/>
+            <a:off x="8861650" y="2967013"/>
             <a:ext cx="195353" cy="121"/>
           </a:xfrm>
           <a:prstGeom prst="straightConnector1">
@@ -4605,7 +4551,7 @@
         </p:nvSpPr>
         <p:spPr>
           <a:xfrm>
-            <a:off x="6674066" y="3126637"/>
+            <a:off x="7069386" y="3408890"/>
             <a:ext cx="1310023" cy="230355"/>
           </a:xfrm>
           <a:prstGeom prst="rect">
@@ -4643,34 +4589,14 @@
           <a:p>
             <a:pPr algn="ctr"/>
             <a:r>
-              <a:rPr lang="en-US" altLang="zh-CN" sz="1050" dirty="0" err="1" smtClean="0">
+              <a:rPr lang="en-US" altLang="zh-CN" sz="1050" dirty="0" smtClean="0">
                 <a:solidFill>
                   <a:schemeClr val="tx1"/>
                 </a:solidFill>
                 <a:latin typeface="微软雅黑" panose="020B0503020204020204" pitchFamily="34" charset="-122"/>
                 <a:ea typeface="微软雅黑" panose="020B0503020204020204" pitchFamily="34" charset="-122"/>
               </a:rPr>
-              <a:t>Armbot</a:t>
-            </a:r>
-            <a:r>
-              <a:rPr lang="en-US" altLang="zh-CN" sz="1050" dirty="0" smtClean="0">
-                <a:solidFill>
-                  <a:schemeClr val="tx1"/>
-                </a:solidFill>
-                <a:latin typeface="微软雅黑" panose="020B0503020204020204" pitchFamily="34" charset="-122"/>
-                <a:ea typeface="微软雅黑" panose="020B0503020204020204" pitchFamily="34" charset="-122"/>
-              </a:rPr>
-              <a:t> </a:t>
-            </a:r>
-            <a:r>
-              <a:rPr lang="en-US" altLang="zh-CN" sz="1050" dirty="0" err="1" smtClean="0">
-                <a:solidFill>
-                  <a:schemeClr val="tx1"/>
-                </a:solidFill>
-                <a:latin typeface="微软雅黑" panose="020B0503020204020204" pitchFamily="34" charset="-122"/>
-                <a:ea typeface="微软雅黑" panose="020B0503020204020204" pitchFamily="34" charset="-122"/>
-              </a:rPr>
-              <a:t>Exeutor</a:t>
+              <a:t>Arm bot Executor</a:t>
             </a:r>
             <a:endParaRPr lang="zh-CN" altLang="en-US" sz="1050" dirty="0">
               <a:solidFill>
@@ -4690,7 +4616,7 @@
         </p:nvSpPr>
         <p:spPr>
           <a:xfrm>
-            <a:off x="8042832" y="3126637"/>
+            <a:off x="8438152" y="3408890"/>
             <a:ext cx="1310023" cy="230355"/>
           </a:xfrm>
           <a:prstGeom prst="rect">
@@ -4738,14 +4664,14 @@
               <a:t>Motor </a:t>
             </a:r>
             <a:r>
-              <a:rPr lang="en-US" altLang="zh-CN" sz="1050" dirty="0" err="1" smtClean="0">
+              <a:rPr lang="en-US" altLang="zh-CN" sz="1050" dirty="0" smtClean="0">
                 <a:solidFill>
                   <a:schemeClr val="tx1"/>
                 </a:solidFill>
                 <a:latin typeface="微软雅黑" panose="020B0503020204020204" pitchFamily="34" charset="-122"/>
                 <a:ea typeface="微软雅黑" panose="020B0503020204020204" pitchFamily="34" charset="-122"/>
               </a:rPr>
-              <a:t>Exeutor</a:t>
+              <a:t>Executor</a:t>
             </a:r>
             <a:endParaRPr lang="zh-CN" altLang="en-US" sz="1050" dirty="0">
               <a:solidFill>
@@ -4768,7 +4694,7 @@
         </p:nvCxnSpPr>
         <p:spPr>
           <a:xfrm rot="5400000">
-            <a:off x="8099359" y="2106585"/>
+            <a:off x="8494679" y="2388838"/>
             <a:ext cx="249772" cy="1790333"/>
           </a:xfrm>
           <a:prstGeom prst="bentConnector3">
@@ -4804,7 +4730,7 @@
         </p:nvCxnSpPr>
         <p:spPr>
           <a:xfrm rot="5400000">
-            <a:off x="8783742" y="2790968"/>
+            <a:off x="9179062" y="3073221"/>
             <a:ext cx="249772" cy="421567"/>
           </a:xfrm>
           <a:prstGeom prst="bentConnector3">
@@ -4832,6 +4758,108 @@
       <p:pic>
         <p:nvPicPr>
           <p:cNvPr id="1044" name="Picture 20"/>
+          <p:cNvPicPr>
+            <a:picLocks noChangeAspect="1" noChangeArrowheads="1"/>
+          </p:cNvPicPr>
+          <p:nvPr/>
+        </p:nvPicPr>
+        <p:blipFill>
+          <a:blip r:embed="rId9" cstate="print">
+            <a:extLst>
+              <a:ext uri="{28A0092B-C50C-407E-A947-70E740481C1C}">
+                <a14:useLocalDpi xmlns:a14="http://schemas.microsoft.com/office/drawing/2010/main" val="0"/>
+              </a:ext>
+            </a:extLst>
+          </a:blip>
+          <a:srcRect/>
+          <a:stretch>
+            <a:fillRect/>
+          </a:stretch>
+        </p:blipFill>
+        <p:spPr bwMode="auto">
+          <a:xfrm flipH="1">
+            <a:off x="7507892" y="4173648"/>
+            <a:ext cx="433013" cy="485769"/>
+          </a:xfrm>
+          <a:prstGeom prst="rect">
+            <a:avLst/>
+          </a:prstGeom>
+          <a:noFill/>
+          <a:ln>
+            <a:noFill/>
+          </a:ln>
+          <a:effectLst/>
+          <a:extLst>
+            <a:ext uri="{909E8E84-426E-40DD-AFC4-6F175D3DCCD1}">
+              <a14:hiddenFill xmlns:a14="http://schemas.microsoft.com/office/drawing/2010/main">
+                <a:solidFill>
+                  <a:schemeClr val="accent1"/>
+                </a:solidFill>
+              </a14:hiddenFill>
+            </a:ext>
+            <a:ext uri="{91240B29-F687-4F45-9708-019B960494DF}">
+              <a14:hiddenLine xmlns:a14="http://schemas.microsoft.com/office/drawing/2010/main" w="9525">
+                <a:solidFill>
+                  <a:schemeClr val="tx1"/>
+                </a:solidFill>
+                <a:miter lim="800000"/>
+                <a:headEnd/>
+                <a:tailEnd/>
+              </a14:hiddenLine>
+            </a:ext>
+            <a:ext uri="{AF507438-7753-43E0-B8FC-AC1667EBCBE1}">
+              <a14:hiddenEffects xmlns:a14="http://schemas.microsoft.com/office/drawing/2010/main">
+                <a:effectLst>
+                  <a:outerShdw dist="35921" dir="2700000" algn="ctr" rotWithShape="0">
+                    <a:schemeClr val="bg2"/>
+                  </a:outerShdw>
+                </a:effectLst>
+              </a14:hiddenEffects>
+            </a:ext>
+          </a:extLst>
+        </p:spPr>
+      </p:pic>
+      <p:cxnSp>
+        <p:nvCxnSpPr>
+          <p:cNvPr id="71" name="直接连接符 70"/>
+          <p:cNvCxnSpPr>
+            <a:stCxn id="76" idx="2"/>
+            <a:endCxn id="1044" idx="0"/>
+          </p:cNvCxnSpPr>
+          <p:nvPr/>
+        </p:nvCxnSpPr>
+        <p:spPr>
+          <a:xfrm>
+            <a:off x="7724398" y="3639245"/>
+            <a:ext cx="0" cy="534403"/>
+          </a:xfrm>
+          <a:prstGeom prst="line">
+            <a:avLst/>
+          </a:prstGeom>
+          <a:ln>
+            <a:solidFill>
+              <a:srgbClr val="C00000"/>
+            </a:solidFill>
+          </a:ln>
+        </p:spPr>
+        <p:style>
+          <a:lnRef idx="1">
+            <a:schemeClr val="accent1"/>
+          </a:lnRef>
+          <a:fillRef idx="0">
+            <a:schemeClr val="accent1"/>
+          </a:fillRef>
+          <a:effectRef idx="0">
+            <a:schemeClr val="accent1"/>
+          </a:effectRef>
+          <a:fontRef idx="minor">
+            <a:schemeClr val="tx1"/>
+          </a:fontRef>
+        </p:style>
+      </p:cxnSp>
+      <p:pic>
+        <p:nvPicPr>
+          <p:cNvPr id="1045" name="Picture 21"/>
           <p:cNvPicPr>
             <a:picLocks noChangeAspect="1" noChangeArrowheads="1"/>
           </p:cNvPicPr>
@@ -4851,9 +4879,9 @@
           </a:stretch>
         </p:blipFill>
         <p:spPr bwMode="auto">
-          <a:xfrm flipH="1">
-            <a:off x="7112572" y="3891395"/>
-            <a:ext cx="433013" cy="485769"/>
+          <a:xfrm>
+            <a:off x="8779233" y="4247706"/>
+            <a:ext cx="407015" cy="411711"/>
           </a:xfrm>
           <a:prstGeom prst="rect">
             <a:avLst/>
@@ -4893,21 +4921,85 @@
           </a:extLst>
         </p:spPr>
       </p:pic>
+      <p:pic>
+        <p:nvPicPr>
+          <p:cNvPr id="91" name="Picture 21"/>
+          <p:cNvPicPr>
+            <a:picLocks noChangeAspect="1" noChangeArrowheads="1"/>
+          </p:cNvPicPr>
+          <p:nvPr/>
+        </p:nvPicPr>
+        <p:blipFill>
+          <a:blip r:embed="rId10" cstate="print">
+            <a:extLst>
+              <a:ext uri="{28A0092B-C50C-407E-A947-70E740481C1C}">
+                <a14:useLocalDpi xmlns:a14="http://schemas.microsoft.com/office/drawing/2010/main" val="0"/>
+              </a:ext>
+            </a:extLst>
+          </a:blip>
+          <a:srcRect/>
+          <a:stretch>
+            <a:fillRect/>
+          </a:stretch>
+        </p:blipFill>
+        <p:spPr bwMode="auto">
+          <a:xfrm>
+            <a:off x="8316275" y="4239694"/>
+            <a:ext cx="407015" cy="411711"/>
+          </a:xfrm>
+          <a:prstGeom prst="rect">
+            <a:avLst/>
+          </a:prstGeom>
+          <a:noFill/>
+          <a:ln>
+            <a:noFill/>
+          </a:ln>
+          <a:effectLst/>
+          <a:extLst>
+            <a:ext uri="{909E8E84-426E-40DD-AFC4-6F175D3DCCD1}">
+              <a14:hiddenFill xmlns:a14="http://schemas.microsoft.com/office/drawing/2010/main">
+                <a:solidFill>
+                  <a:schemeClr val="accent1"/>
+                </a:solidFill>
+              </a14:hiddenFill>
+            </a:ext>
+            <a:ext uri="{91240B29-F687-4F45-9708-019B960494DF}">
+              <a14:hiddenLine xmlns:a14="http://schemas.microsoft.com/office/drawing/2010/main" w="9525">
+                <a:solidFill>
+                  <a:schemeClr val="tx1"/>
+                </a:solidFill>
+                <a:miter lim="800000"/>
+                <a:headEnd/>
+                <a:tailEnd/>
+              </a14:hiddenLine>
+            </a:ext>
+            <a:ext uri="{AF507438-7753-43E0-B8FC-AC1667EBCBE1}">
+              <a14:hiddenEffects xmlns:a14="http://schemas.microsoft.com/office/drawing/2010/main">
+                <a:effectLst>
+                  <a:outerShdw dist="35921" dir="2700000" algn="ctr" rotWithShape="0">
+                    <a:schemeClr val="bg2"/>
+                  </a:outerShdw>
+                </a:effectLst>
+              </a14:hiddenEffects>
+            </a:ext>
+          </a:extLst>
+        </p:spPr>
+      </p:pic>
       <p:cxnSp>
         <p:nvCxnSpPr>
-          <p:cNvPr id="71" name="直接连接符 70"/>
+          <p:cNvPr id="79" name="肘形连接符 78"/>
           <p:cNvCxnSpPr>
-            <a:stCxn id="76" idx="2"/>
-            <a:endCxn id="1044" idx="0"/>
+            <a:stCxn id="75" idx="2"/>
+            <a:endCxn id="91" idx="0"/>
           </p:cNvCxnSpPr>
           <p:nvPr/>
         </p:nvCxnSpPr>
         <p:spPr>
-          <a:xfrm>
-            <a:off x="7329078" y="3356992"/>
-            <a:ext cx="0" cy="534403"/>
-          </a:xfrm>
-          <a:prstGeom prst="line">
+          <a:xfrm rot="5400000">
+            <a:off x="8742323" y="3888854"/>
+            <a:ext cx="128300" cy="573380"/>
+          </a:xfrm>
+          <a:prstGeom prst="bentConnector3">
             <a:avLst/>
           </a:prstGeom>
           <a:ln>
@@ -4933,7 +5025,255 @@
       </p:cxnSp>
       <p:pic>
         <p:nvPicPr>
-          <p:cNvPr id="1045" name="Picture 21"/>
+          <p:cNvPr id="94" name="Picture 21"/>
+          <p:cNvPicPr>
+            <a:picLocks noChangeAspect="1" noChangeArrowheads="1"/>
+          </p:cNvPicPr>
+          <p:nvPr/>
+        </p:nvPicPr>
+        <p:blipFill>
+          <a:blip r:embed="rId10" cstate="print">
+            <a:extLst>
+              <a:ext uri="{28A0092B-C50C-407E-A947-70E740481C1C}">
+                <a14:useLocalDpi xmlns:a14="http://schemas.microsoft.com/office/drawing/2010/main" val="0"/>
+              </a:ext>
+            </a:extLst>
+          </a:blip>
+          <a:srcRect/>
+          <a:stretch>
+            <a:fillRect/>
+          </a:stretch>
+        </p:blipFill>
+        <p:spPr bwMode="auto">
+          <a:xfrm>
+            <a:off x="9697580" y="4247706"/>
+            <a:ext cx="407015" cy="411711"/>
+          </a:xfrm>
+          <a:prstGeom prst="rect">
+            <a:avLst/>
+          </a:prstGeom>
+          <a:noFill/>
+          <a:ln>
+            <a:noFill/>
+          </a:ln>
+          <a:effectLst/>
+          <a:extLst>
+            <a:ext uri="{909E8E84-426E-40DD-AFC4-6F175D3DCCD1}">
+              <a14:hiddenFill xmlns:a14="http://schemas.microsoft.com/office/drawing/2010/main">
+                <a:solidFill>
+                  <a:schemeClr val="accent1"/>
+                </a:solidFill>
+              </a14:hiddenFill>
+            </a:ext>
+            <a:ext uri="{91240B29-F687-4F45-9708-019B960494DF}">
+              <a14:hiddenLine xmlns:a14="http://schemas.microsoft.com/office/drawing/2010/main" w="9525">
+                <a:solidFill>
+                  <a:schemeClr val="tx1"/>
+                </a:solidFill>
+                <a:miter lim="800000"/>
+                <a:headEnd/>
+                <a:tailEnd/>
+              </a14:hiddenLine>
+            </a:ext>
+            <a:ext uri="{AF507438-7753-43E0-B8FC-AC1667EBCBE1}">
+              <a14:hiddenEffects xmlns:a14="http://schemas.microsoft.com/office/drawing/2010/main">
+                <a:effectLst>
+                  <a:outerShdw dist="35921" dir="2700000" algn="ctr" rotWithShape="0">
+                    <a:schemeClr val="bg2"/>
+                  </a:outerShdw>
+                </a:effectLst>
+              </a14:hiddenEffects>
+            </a:ext>
+          </a:extLst>
+        </p:spPr>
+      </p:pic>
+      <p:pic>
+        <p:nvPicPr>
+          <p:cNvPr id="95" name="Picture 21"/>
+          <p:cNvPicPr>
+            <a:picLocks noChangeAspect="1" noChangeArrowheads="1"/>
+          </p:cNvPicPr>
+          <p:nvPr/>
+        </p:nvPicPr>
+        <p:blipFill>
+          <a:blip r:embed="rId10" cstate="print">
+            <a:extLst>
+              <a:ext uri="{28A0092B-C50C-407E-A947-70E740481C1C}">
+                <a14:useLocalDpi xmlns:a14="http://schemas.microsoft.com/office/drawing/2010/main" val="0"/>
+              </a:ext>
+            </a:extLst>
+          </a:blip>
+          <a:srcRect/>
+          <a:stretch>
+            <a:fillRect/>
+          </a:stretch>
+        </p:blipFill>
+        <p:spPr bwMode="auto">
+          <a:xfrm>
+            <a:off x="9234622" y="4239694"/>
+            <a:ext cx="407015" cy="411711"/>
+          </a:xfrm>
+          <a:prstGeom prst="rect">
+            <a:avLst/>
+          </a:prstGeom>
+          <a:noFill/>
+          <a:ln>
+            <a:noFill/>
+          </a:ln>
+          <a:effectLst/>
+          <a:extLst>
+            <a:ext uri="{909E8E84-426E-40DD-AFC4-6F175D3DCCD1}">
+              <a14:hiddenFill xmlns:a14="http://schemas.microsoft.com/office/drawing/2010/main">
+                <a:solidFill>
+                  <a:schemeClr val="accent1"/>
+                </a:solidFill>
+              </a14:hiddenFill>
+            </a:ext>
+            <a:ext uri="{91240B29-F687-4F45-9708-019B960494DF}">
+              <a14:hiddenLine xmlns:a14="http://schemas.microsoft.com/office/drawing/2010/main" w="9525">
+                <a:solidFill>
+                  <a:schemeClr val="tx1"/>
+                </a:solidFill>
+                <a:miter lim="800000"/>
+                <a:headEnd/>
+                <a:tailEnd/>
+              </a14:hiddenLine>
+            </a:ext>
+            <a:ext uri="{AF507438-7753-43E0-B8FC-AC1667EBCBE1}">
+              <a14:hiddenEffects xmlns:a14="http://schemas.microsoft.com/office/drawing/2010/main">
+                <a:effectLst>
+                  <a:outerShdw dist="35921" dir="2700000" algn="ctr" rotWithShape="0">
+                    <a:schemeClr val="bg2"/>
+                  </a:outerShdw>
+                </a:effectLst>
+              </a14:hiddenEffects>
+            </a:ext>
+          </a:extLst>
+        </p:spPr>
+      </p:pic>
+      <p:cxnSp>
+        <p:nvCxnSpPr>
+          <p:cNvPr id="96" name="肘形连接符 95"/>
+          <p:cNvCxnSpPr>
+            <a:stCxn id="75" idx="2"/>
+            <a:endCxn id="1045" idx="0"/>
+          </p:cNvCxnSpPr>
+          <p:nvPr/>
+        </p:nvCxnSpPr>
+        <p:spPr>
+          <a:xfrm rot="5400000">
+            <a:off x="8969796" y="4124339"/>
+            <a:ext cx="136312" cy="110422"/>
+          </a:xfrm>
+          <a:prstGeom prst="bentConnector3">
+            <a:avLst>
+              <a:gd name="adj1" fmla="val 50000"/>
+            </a:avLst>
+          </a:prstGeom>
+          <a:ln>
+            <a:solidFill>
+              <a:srgbClr val="C00000"/>
+            </a:solidFill>
+          </a:ln>
+        </p:spPr>
+        <p:style>
+          <a:lnRef idx="1">
+            <a:schemeClr val="accent1"/>
+          </a:lnRef>
+          <a:fillRef idx="0">
+            <a:schemeClr val="accent1"/>
+          </a:fillRef>
+          <a:effectRef idx="0">
+            <a:schemeClr val="accent1"/>
+          </a:effectRef>
+          <a:fontRef idx="minor">
+            <a:schemeClr val="tx1"/>
+          </a:fontRef>
+        </p:style>
+      </p:cxnSp>
+      <p:cxnSp>
+        <p:nvCxnSpPr>
+          <p:cNvPr id="99" name="肘形连接符 98"/>
+          <p:cNvCxnSpPr>
+            <a:stCxn id="75" idx="2"/>
+            <a:endCxn id="95" idx="0"/>
+          </p:cNvCxnSpPr>
+          <p:nvPr/>
+        </p:nvCxnSpPr>
+        <p:spPr>
+          <a:xfrm rot="16200000" flipH="1">
+            <a:off x="9201496" y="4003060"/>
+            <a:ext cx="128300" cy="344967"/>
+          </a:xfrm>
+          <a:prstGeom prst="bentConnector3">
+            <a:avLst>
+              <a:gd name="adj1" fmla="val 50000"/>
+            </a:avLst>
+          </a:prstGeom>
+          <a:ln>
+            <a:solidFill>
+              <a:srgbClr val="C00000"/>
+            </a:solidFill>
+          </a:ln>
+        </p:spPr>
+        <p:style>
+          <a:lnRef idx="1">
+            <a:schemeClr val="accent1"/>
+          </a:lnRef>
+          <a:fillRef idx="0">
+            <a:schemeClr val="accent1"/>
+          </a:fillRef>
+          <a:effectRef idx="0">
+            <a:schemeClr val="accent1"/>
+          </a:effectRef>
+          <a:fontRef idx="minor">
+            <a:schemeClr val="tx1"/>
+          </a:fontRef>
+        </p:style>
+      </p:cxnSp>
+      <p:cxnSp>
+        <p:nvCxnSpPr>
+          <p:cNvPr id="102" name="肘形连接符 101"/>
+          <p:cNvCxnSpPr>
+            <a:stCxn id="75" idx="2"/>
+            <a:endCxn id="94" idx="0"/>
+          </p:cNvCxnSpPr>
+          <p:nvPr/>
+        </p:nvCxnSpPr>
+        <p:spPr>
+          <a:xfrm rot="16200000" flipH="1">
+            <a:off x="9428969" y="3775587"/>
+            <a:ext cx="136312" cy="807925"/>
+          </a:xfrm>
+          <a:prstGeom prst="bentConnector3">
+            <a:avLst>
+              <a:gd name="adj1" fmla="val 50000"/>
+            </a:avLst>
+          </a:prstGeom>
+          <a:ln>
+            <a:solidFill>
+              <a:srgbClr val="C00000"/>
+            </a:solidFill>
+          </a:ln>
+        </p:spPr>
+        <p:style>
+          <a:lnRef idx="1">
+            <a:schemeClr val="accent1"/>
+          </a:lnRef>
+          <a:fillRef idx="0">
+            <a:schemeClr val="accent1"/>
+          </a:fillRef>
+          <a:effectRef idx="0">
+            <a:schemeClr val="accent1"/>
+          </a:effectRef>
+          <a:fontRef idx="minor">
+            <a:schemeClr val="tx1"/>
+          </a:fontRef>
+        </p:style>
+      </p:cxnSp>
+      <p:pic>
+        <p:nvPicPr>
+          <p:cNvPr id="1046" name="Picture 22"/>
           <p:cNvPicPr>
             <a:picLocks noChangeAspect="1" noChangeArrowheads="1"/>
           </p:cNvPicPr>
@@ -4954,8 +5294,8 @@
         </p:blipFill>
         <p:spPr bwMode="auto">
           <a:xfrm>
-            <a:off x="8383913" y="3965453"/>
-            <a:ext cx="407015" cy="411711"/>
+            <a:off x="10108657" y="1734829"/>
+            <a:ext cx="451613" cy="404393"/>
           </a:xfrm>
           <a:prstGeom prst="rect">
             <a:avLst/>
@@ -4995,85 +5335,79 @@
           </a:extLst>
         </p:spPr>
       </p:pic>
-      <p:pic>
-        <p:nvPicPr>
-          <p:cNvPr id="91" name="Picture 21"/>
-          <p:cNvPicPr>
-            <a:picLocks noChangeAspect="1" noChangeArrowheads="1"/>
-          </p:cNvPicPr>
+      <p:sp>
+        <p:nvSpPr>
+          <p:cNvPr id="106" name="矩形 105"/>
+          <p:cNvSpPr/>
           <p:nvPr/>
-        </p:nvPicPr>
-        <p:blipFill>
-          <a:blip r:embed="rId11" cstate="print">
-            <a:extLst>
-              <a:ext uri="{28A0092B-C50C-407E-A947-70E740481C1C}">
-                <a14:useLocalDpi xmlns:a14="http://schemas.microsoft.com/office/drawing/2010/main" val="0"/>
-              </a:ext>
-            </a:extLst>
-          </a:blip>
-          <a:srcRect/>
-          <a:stretch>
-            <a:fillRect/>
-          </a:stretch>
-        </p:blipFill>
-        <p:spPr bwMode="auto">
-          <a:xfrm>
-            <a:off x="7920955" y="3957441"/>
-            <a:ext cx="407015" cy="411711"/>
+        </p:nvSpPr>
+        <p:spPr>
+          <a:xfrm>
+            <a:off x="8742404" y="1781331"/>
+            <a:ext cx="928121" cy="311388"/>
           </a:xfrm>
           <a:prstGeom prst="rect">
             <a:avLst/>
           </a:prstGeom>
           <a:noFill/>
-          <a:ln>
-            <a:noFill/>
-          </a:ln>
-          <a:effectLst/>
-          <a:extLst>
-            <a:ext uri="{909E8E84-426E-40DD-AFC4-6F175D3DCCD1}">
-              <a14:hiddenFill xmlns:a14="http://schemas.microsoft.com/office/drawing/2010/main">
-                <a:solidFill>
-                  <a:schemeClr val="accent1"/>
-                </a:solidFill>
-              </a14:hiddenFill>
-            </a:ext>
-            <a:ext uri="{91240B29-F687-4F45-9708-019B960494DF}">
-              <a14:hiddenLine xmlns:a14="http://schemas.microsoft.com/office/drawing/2010/main" w="9525">
+          <a:ln w="12700"/>
+        </p:spPr>
+        <p:style>
+          <a:lnRef idx="2">
+            <a:schemeClr val="accent1">
+              <a:shade val="50000"/>
+            </a:schemeClr>
+          </a:lnRef>
+          <a:fillRef idx="1">
+            <a:schemeClr val="accent1"/>
+          </a:fillRef>
+          <a:effectRef idx="0">
+            <a:schemeClr val="accent1"/>
+          </a:effectRef>
+          <a:fontRef idx="minor">
+            <a:schemeClr val="lt1"/>
+          </a:fontRef>
+        </p:style>
+        <p:txBody>
+          <a:bodyPr rtlCol="0" anchor="ctr"/>
+          <a:lstStyle/>
+          <a:p>
+            <a:pPr algn="ctr"/>
+            <a:r>
+              <a:rPr lang="en-US" altLang="zh-CN" sz="1200" dirty="0" smtClean="0">
                 <a:solidFill>
                   <a:schemeClr val="tx1"/>
                 </a:solidFill>
-                <a:miter lim="800000"/>
-                <a:headEnd/>
-                <a:tailEnd/>
-              </a14:hiddenLine>
-            </a:ext>
-            <a:ext uri="{AF507438-7753-43E0-B8FC-AC1667EBCBE1}">
-              <a14:hiddenEffects xmlns:a14="http://schemas.microsoft.com/office/drawing/2010/main">
-                <a:effectLst>
-                  <a:outerShdw dist="35921" dir="2700000" algn="ctr" rotWithShape="0">
-                    <a:schemeClr val="bg2"/>
-                  </a:outerShdw>
-                </a:effectLst>
-              </a14:hiddenEffects>
-            </a:ext>
-          </a:extLst>
-        </p:spPr>
-      </p:pic>
+                <a:latin typeface="微软雅黑" panose="020B0503020204020204" pitchFamily="34" charset="-122"/>
+                <a:ea typeface="微软雅黑" panose="020B0503020204020204" pitchFamily="34" charset="-122"/>
+              </a:rPr>
+              <a:t>JQ6500</a:t>
+            </a:r>
+            <a:endParaRPr lang="zh-CN" altLang="en-US" sz="1200" dirty="0">
+              <a:solidFill>
+                <a:schemeClr val="tx1"/>
+              </a:solidFill>
+              <a:latin typeface="微软雅黑" panose="020B0503020204020204" pitchFamily="34" charset="-122"/>
+              <a:ea typeface="微软雅黑" panose="020B0503020204020204" pitchFamily="34" charset="-122"/>
+            </a:endParaRPr>
+          </a:p>
+        </p:txBody>
+      </p:sp>
       <p:cxnSp>
         <p:nvCxnSpPr>
-          <p:cNvPr id="79" name="肘形连接符 78"/>
+          <p:cNvPr id="88" name="直接连接符 87"/>
           <p:cNvCxnSpPr>
-            <a:stCxn id="75" idx="2"/>
-            <a:endCxn id="91" idx="0"/>
+            <a:stCxn id="106" idx="3"/>
+            <a:endCxn id="1046" idx="1"/>
           </p:cNvCxnSpPr>
           <p:nvPr/>
         </p:nvCxnSpPr>
         <p:spPr>
-          <a:xfrm rot="5400000">
-            <a:off x="8347003" y="3606601"/>
-            <a:ext cx="128300" cy="573380"/>
-          </a:xfrm>
-          <a:prstGeom prst="bentConnector3">
+          <a:xfrm>
+            <a:off x="9670525" y="1937025"/>
+            <a:ext cx="438132" cy="1"/>
+          </a:xfrm>
+          <a:prstGeom prst="line">
             <a:avLst/>
           </a:prstGeom>
           <a:ln>
@@ -5097,152 +5431,66 @@
           </a:fontRef>
         </p:style>
       </p:cxnSp>
-      <p:pic>
-        <p:nvPicPr>
-          <p:cNvPr id="94" name="Picture 21"/>
-          <p:cNvPicPr>
-            <a:picLocks noChangeAspect="1" noChangeArrowheads="1"/>
-          </p:cNvPicPr>
+      <p:sp>
+        <p:nvSpPr>
+          <p:cNvPr id="89" name="矩形 88"/>
+          <p:cNvSpPr/>
           <p:nvPr/>
-        </p:nvPicPr>
-        <p:blipFill>
-          <a:blip r:embed="rId11" cstate="print">
-            <a:extLst>
-              <a:ext uri="{28A0092B-C50C-407E-A947-70E740481C1C}">
-                <a14:useLocalDpi xmlns:a14="http://schemas.microsoft.com/office/drawing/2010/main" val="0"/>
-              </a:ext>
-            </a:extLst>
-          </a:blip>
-          <a:srcRect/>
-          <a:stretch>
-            <a:fillRect/>
-          </a:stretch>
-        </p:blipFill>
-        <p:spPr bwMode="auto">
-          <a:xfrm>
-            <a:off x="9302260" y="3965453"/>
-            <a:ext cx="407015" cy="411711"/>
+        </p:nvSpPr>
+        <p:spPr>
+          <a:xfrm>
+            <a:off x="8368697" y="2107790"/>
+            <a:ext cx="156765" cy="203879"/>
           </a:xfrm>
           <a:prstGeom prst="rect">
             <a:avLst/>
           </a:prstGeom>
-          <a:noFill/>
-          <a:ln>
-            <a:noFill/>
-          </a:ln>
-          <a:effectLst/>
-          <a:extLst>
-            <a:ext uri="{909E8E84-426E-40DD-AFC4-6F175D3DCCD1}">
-              <a14:hiddenFill xmlns:a14="http://schemas.microsoft.com/office/drawing/2010/main">
-                <a:solidFill>
-                  <a:schemeClr val="accent1"/>
-                </a:solidFill>
-              </a14:hiddenFill>
-            </a:ext>
-            <a:ext uri="{91240B29-F687-4F45-9708-019B960494DF}">
-              <a14:hiddenLine xmlns:a14="http://schemas.microsoft.com/office/drawing/2010/main" w="9525">
-                <a:solidFill>
-                  <a:schemeClr val="tx1"/>
-                </a:solidFill>
-                <a:miter lim="800000"/>
-                <a:headEnd/>
-                <a:tailEnd/>
-              </a14:hiddenLine>
-            </a:ext>
-            <a:ext uri="{AF507438-7753-43E0-B8FC-AC1667EBCBE1}">
-              <a14:hiddenEffects xmlns:a14="http://schemas.microsoft.com/office/drawing/2010/main">
-                <a:effectLst>
-                  <a:outerShdw dist="35921" dir="2700000" algn="ctr" rotWithShape="0">
-                    <a:schemeClr val="bg2"/>
-                  </a:outerShdw>
-                </a:effectLst>
-              </a14:hiddenEffects>
-            </a:ext>
-          </a:extLst>
-        </p:spPr>
-      </p:pic>
-      <p:pic>
-        <p:nvPicPr>
-          <p:cNvPr id="95" name="Picture 21"/>
-          <p:cNvPicPr>
-            <a:picLocks noChangeAspect="1" noChangeArrowheads="1"/>
-          </p:cNvPicPr>
-          <p:nvPr/>
-        </p:nvPicPr>
-        <p:blipFill>
-          <a:blip r:embed="rId11" cstate="print">
-            <a:extLst>
-              <a:ext uri="{28A0092B-C50C-407E-A947-70E740481C1C}">
-                <a14:useLocalDpi xmlns:a14="http://schemas.microsoft.com/office/drawing/2010/main" val="0"/>
-              </a:ext>
-            </a:extLst>
-          </a:blip>
-          <a:srcRect/>
-          <a:stretch>
-            <a:fillRect/>
-          </a:stretch>
-        </p:blipFill>
-        <p:spPr bwMode="auto">
-          <a:xfrm>
-            <a:off x="8839302" y="3957441"/>
-            <a:ext cx="407015" cy="411711"/>
-          </a:xfrm>
-          <a:prstGeom prst="rect">
-            <a:avLst/>
-          </a:prstGeom>
-          <a:noFill/>
-          <a:ln>
-            <a:noFill/>
-          </a:ln>
-          <a:effectLst/>
-          <a:extLst>
-            <a:ext uri="{909E8E84-426E-40DD-AFC4-6F175D3DCCD1}">
-              <a14:hiddenFill xmlns:a14="http://schemas.microsoft.com/office/drawing/2010/main">
-                <a:solidFill>
-                  <a:schemeClr val="accent1"/>
-                </a:solidFill>
-              </a14:hiddenFill>
-            </a:ext>
-            <a:ext uri="{91240B29-F687-4F45-9708-019B960494DF}">
-              <a14:hiddenLine xmlns:a14="http://schemas.microsoft.com/office/drawing/2010/main" w="9525">
-                <a:solidFill>
-                  <a:schemeClr val="tx1"/>
-                </a:solidFill>
-                <a:miter lim="800000"/>
-                <a:headEnd/>
-                <a:tailEnd/>
-              </a14:hiddenLine>
-            </a:ext>
-            <a:ext uri="{AF507438-7753-43E0-B8FC-AC1667EBCBE1}">
-              <a14:hiddenEffects xmlns:a14="http://schemas.microsoft.com/office/drawing/2010/main">
-                <a:effectLst>
-                  <a:outerShdw dist="35921" dir="2700000" algn="ctr" rotWithShape="0">
-                    <a:schemeClr val="bg2"/>
-                  </a:outerShdw>
-                </a:effectLst>
-              </a14:hiddenEffects>
-            </a:ext>
-          </a:extLst>
-        </p:spPr>
-      </p:pic>
+          <a:solidFill>
+            <a:schemeClr val="bg1"/>
+          </a:solidFill>
+          <a:ln w="12700"/>
+        </p:spPr>
+        <p:style>
+          <a:lnRef idx="2">
+            <a:schemeClr val="accent1">
+              <a:shade val="50000"/>
+            </a:schemeClr>
+          </a:lnRef>
+          <a:fillRef idx="1">
+            <a:schemeClr val="accent1"/>
+          </a:fillRef>
+          <a:effectRef idx="0">
+            <a:schemeClr val="accent1"/>
+          </a:effectRef>
+          <a:fontRef idx="minor">
+            <a:schemeClr val="lt1"/>
+          </a:fontRef>
+        </p:style>
+        <p:txBody>
+          <a:bodyPr rtlCol="0" anchor="ctr"/>
+          <a:lstStyle/>
+          <a:p>
+            <a:pPr algn="ctr"/>
+            <a:endParaRPr lang="zh-CN" altLang="en-US"/>
+          </a:p>
+        </p:txBody>
+      </p:sp>
       <p:cxnSp>
         <p:nvCxnSpPr>
-          <p:cNvPr id="96" name="肘形连接符 95"/>
+          <p:cNvPr id="92" name="肘形连接符 91"/>
           <p:cNvCxnSpPr>
-            <a:stCxn id="75" idx="2"/>
-            <a:endCxn id="1045" idx="0"/>
+            <a:stCxn id="89" idx="0"/>
+            <a:endCxn id="106" idx="1"/>
           </p:cNvCxnSpPr>
           <p:nvPr/>
         </p:nvCxnSpPr>
         <p:spPr>
-          <a:xfrm rot="5400000">
-            <a:off x="8574476" y="3842086"/>
-            <a:ext cx="136312" cy="110422"/>
-          </a:xfrm>
-          <a:prstGeom prst="bentConnector3">
-            <a:avLst>
-              <a:gd name="adj1" fmla="val 50000"/>
-            </a:avLst>
+          <a:xfrm rot="5400000" flipH="1" flipV="1">
+            <a:off x="8509360" y="1874746"/>
+            <a:ext cx="170765" cy="295324"/>
+          </a:xfrm>
+          <a:prstGeom prst="bentConnector2">
+            <a:avLst/>
           </a:prstGeom>
           <a:ln>
             <a:solidFill>
@@ -5267,22 +5515,114 @@
       </p:cxnSp>
       <p:cxnSp>
         <p:nvCxnSpPr>
-          <p:cNvPr id="99" name="肘形连接符 98"/>
+          <p:cNvPr id="4" name="直接箭头连接符 3"/>
           <p:cNvCxnSpPr>
-            <a:stCxn id="75" idx="2"/>
-            <a:endCxn id="95" idx="0"/>
+            <a:stCxn id="28" idx="3"/>
+            <a:endCxn id="58" idx="1"/>
           </p:cNvCxnSpPr>
           <p:nvPr/>
         </p:nvCxnSpPr>
         <p:spPr>
-          <a:xfrm rot="16200000" flipH="1">
-            <a:off x="8806176" y="3720807"/>
-            <a:ext cx="128300" cy="344967"/>
-          </a:xfrm>
-          <a:prstGeom prst="bentConnector3">
-            <a:avLst>
-              <a:gd name="adj1" fmla="val 50000"/>
-            </a:avLst>
+          <a:xfrm>
+            <a:off x="8148116" y="2967134"/>
+            <a:ext cx="119829" cy="3726"/>
+          </a:xfrm>
+          <a:prstGeom prst="straightConnector1">
+            <a:avLst/>
+          </a:prstGeom>
+          <a:ln>
+            <a:tailEnd type="arrow"/>
+          </a:ln>
+        </p:spPr>
+        <p:style>
+          <a:lnRef idx="1">
+            <a:schemeClr val="accent1"/>
+          </a:lnRef>
+          <a:fillRef idx="0">
+            <a:schemeClr val="accent1"/>
+          </a:fillRef>
+          <a:effectRef idx="0">
+            <a:schemeClr val="accent1"/>
+          </a:effectRef>
+          <a:fontRef idx="minor">
+            <a:schemeClr val="tx1"/>
+          </a:fontRef>
+        </p:style>
+      </p:cxnSp>
+      <p:sp>
+        <p:nvSpPr>
+          <p:cNvPr id="75" name="矩形 74"/>
+          <p:cNvSpPr/>
+          <p:nvPr/>
+        </p:nvSpPr>
+        <p:spPr>
+          <a:xfrm>
+            <a:off x="8458376" y="3873380"/>
+            <a:ext cx="1269574" cy="238014"/>
+          </a:xfrm>
+          <a:prstGeom prst="rect">
+            <a:avLst/>
+          </a:prstGeom>
+          <a:noFill/>
+          <a:ln w="12700"/>
+        </p:spPr>
+        <p:style>
+          <a:lnRef idx="2">
+            <a:schemeClr val="accent1">
+              <a:shade val="50000"/>
+            </a:schemeClr>
+          </a:lnRef>
+          <a:fillRef idx="1">
+            <a:schemeClr val="accent1"/>
+          </a:fillRef>
+          <a:effectRef idx="0">
+            <a:schemeClr val="accent1"/>
+          </a:effectRef>
+          <a:fontRef idx="minor">
+            <a:schemeClr val="lt1"/>
+          </a:fontRef>
+        </p:style>
+        <p:txBody>
+          <a:bodyPr rtlCol="0" anchor="ctr"/>
+          <a:lstStyle/>
+          <a:p>
+            <a:pPr algn="ctr"/>
+            <a:r>
+              <a:rPr lang="en-US" altLang="zh-CN" sz="1200" dirty="0">
+                <a:solidFill>
+                  <a:schemeClr val="tx1"/>
+                </a:solidFill>
+                <a:latin typeface="微软雅黑" panose="020B0503020204020204" pitchFamily="34" charset="-122"/>
+                <a:ea typeface="微软雅黑" panose="020B0503020204020204" pitchFamily="34" charset="-122"/>
+              </a:rPr>
+              <a:t>L298N</a:t>
+            </a:r>
+            <a:endParaRPr lang="zh-CN" altLang="en-US" sz="1200" dirty="0">
+              <a:solidFill>
+                <a:schemeClr val="tx1"/>
+              </a:solidFill>
+              <a:latin typeface="微软雅黑" panose="020B0503020204020204" pitchFamily="34" charset="-122"/>
+              <a:ea typeface="微软雅黑" panose="020B0503020204020204" pitchFamily="34" charset="-122"/>
+            </a:endParaRPr>
+          </a:p>
+        </p:txBody>
+      </p:sp>
+      <p:cxnSp>
+        <p:nvCxnSpPr>
+          <p:cNvPr id="47" name="直接连接符 46"/>
+          <p:cNvCxnSpPr>
+            <a:stCxn id="77" idx="2"/>
+            <a:endCxn id="75" idx="0"/>
+          </p:cNvCxnSpPr>
+          <p:nvPr/>
+        </p:nvCxnSpPr>
+        <p:spPr>
+          <a:xfrm flipH="1">
+            <a:off x="9093163" y="3639245"/>
+            <a:ext cx="1" cy="234135"/>
+          </a:xfrm>
+          <a:prstGeom prst="line">
+            <a:avLst/>
           </a:prstGeom>
           <a:ln>
             <a:solidFill>
@@ -5307,27 +5647,23 @@
       </p:cxnSp>
       <p:cxnSp>
         <p:nvCxnSpPr>
-          <p:cNvPr id="102" name="肘形连接符 101"/>
+          <p:cNvPr id="59" name="肘形连接符 58"/>
           <p:cNvCxnSpPr>
-            <a:stCxn id="75" idx="2"/>
-            <a:endCxn id="94" idx="0"/>
+            <a:stCxn id="44" idx="3"/>
+            <a:endCxn id="28" idx="1"/>
           </p:cNvCxnSpPr>
           <p:nvPr/>
         </p:nvCxnSpPr>
         <p:spPr>
-          <a:xfrm rot="16200000" flipH="1">
-            <a:off x="9033649" y="3493334"/>
-            <a:ext cx="136312" cy="807925"/>
+          <a:xfrm>
+            <a:off x="7015765" y="2568282"/>
+            <a:ext cx="236671" cy="398852"/>
           </a:xfrm>
           <a:prstGeom prst="bentConnector3">
-            <a:avLst>
-              <a:gd name="adj1" fmla="val 50000"/>
-            </a:avLst>
+            <a:avLst/>
           </a:prstGeom>
           <a:ln>
-            <a:solidFill>
-              <a:srgbClr val="C00000"/>
-            </a:solidFill>
+            <a:tailEnd type="arrow"/>
           </a:ln>
         </p:spPr>
         <p:style>
@@ -5345,9 +5681,38 @@
           </a:fontRef>
         </p:style>
       </p:cxnSp>
+      <p:sp>
+        <p:nvSpPr>
+          <p:cNvPr id="81" name="矩形 80"/>
+          <p:cNvSpPr/>
+          <p:nvPr/>
+        </p:nvSpPr>
+        <p:spPr>
+          <a:xfrm>
+            <a:off x="4682047" y="3591842"/>
+            <a:ext cx="397866" cy="200055"/>
+          </a:xfrm>
+          <a:prstGeom prst="rect">
+            <a:avLst/>
+          </a:prstGeom>
+        </p:spPr>
+        <p:txBody>
+          <a:bodyPr wrap="none">
+            <a:spAutoFit/>
+          </a:bodyPr>
+          <a:lstStyle/>
+          <a:p>
+            <a:r>
+              <a:rPr lang="en-US" altLang="zh-CN" sz="700" dirty="0"/>
+              <a:t>Radar</a:t>
+            </a:r>
+            <a:endParaRPr lang="zh-CN" altLang="en-US" sz="700" dirty="0"/>
+          </a:p>
+        </p:txBody>
+      </p:sp>
       <p:pic>
         <p:nvPicPr>
-          <p:cNvPr id="1046" name="Picture 22"/>
+          <p:cNvPr id="1026" name="Picture 2"/>
           <p:cNvPicPr>
             <a:picLocks noChangeAspect="1" noChangeArrowheads="1"/>
           </p:cNvPicPr>
@@ -5368,8 +5733,8 @@
         </p:blipFill>
         <p:spPr bwMode="auto">
           <a:xfrm>
-            <a:off x="9713337" y="1452576"/>
-            <a:ext cx="451613" cy="404393"/>
+            <a:off x="1087538" y="1274044"/>
+            <a:ext cx="2315828" cy="1281813"/>
           </a:xfrm>
           <a:prstGeom prst="rect">
             <a:avLst/>
@@ -5411,482 +5776,13 @@
       </p:pic>
       <p:sp>
         <p:nvSpPr>
-          <p:cNvPr id="106" name="矩形 105"/>
-          <p:cNvSpPr/>
-          <p:nvPr/>
-        </p:nvSpPr>
-        <p:spPr>
-          <a:xfrm>
-            <a:off x="8347084" y="1499078"/>
-            <a:ext cx="928121" cy="311388"/>
-          </a:xfrm>
-          <a:prstGeom prst="rect">
-            <a:avLst/>
-          </a:prstGeom>
-          <a:noFill/>
-          <a:ln w="12700"/>
-        </p:spPr>
-        <p:style>
-          <a:lnRef idx="2">
-            <a:schemeClr val="accent1">
-              <a:shade val="50000"/>
-            </a:schemeClr>
-          </a:lnRef>
-          <a:fillRef idx="1">
-            <a:schemeClr val="accent1"/>
-          </a:fillRef>
-          <a:effectRef idx="0">
-            <a:schemeClr val="accent1"/>
-          </a:effectRef>
-          <a:fontRef idx="minor">
-            <a:schemeClr val="lt1"/>
-          </a:fontRef>
-        </p:style>
-        <p:txBody>
-          <a:bodyPr rtlCol="0" anchor="ctr"/>
-          <a:lstStyle/>
-          <a:p>
-            <a:pPr algn="ctr"/>
-            <a:r>
-              <a:rPr lang="en-US" altLang="zh-CN" sz="1200" dirty="0" smtClean="0">
-                <a:solidFill>
-                  <a:schemeClr val="tx1"/>
-                </a:solidFill>
-                <a:latin typeface="微软雅黑" panose="020B0503020204020204" pitchFamily="34" charset="-122"/>
-                <a:ea typeface="微软雅黑" panose="020B0503020204020204" pitchFamily="34" charset="-122"/>
-              </a:rPr>
-              <a:t>JQ6500</a:t>
-            </a:r>
-            <a:endParaRPr lang="zh-CN" altLang="en-US" sz="1200" dirty="0">
-              <a:solidFill>
-                <a:schemeClr val="tx1"/>
-              </a:solidFill>
-              <a:latin typeface="微软雅黑" panose="020B0503020204020204" pitchFamily="34" charset="-122"/>
-              <a:ea typeface="微软雅黑" panose="020B0503020204020204" pitchFamily="34" charset="-122"/>
-            </a:endParaRPr>
-          </a:p>
-        </p:txBody>
-      </p:sp>
-      <p:cxnSp>
-        <p:nvCxnSpPr>
-          <p:cNvPr id="88" name="直接连接符 87"/>
-          <p:cNvCxnSpPr>
-            <a:stCxn id="106" idx="3"/>
-            <a:endCxn id="1046" idx="1"/>
-          </p:cNvCxnSpPr>
-          <p:nvPr/>
-        </p:nvCxnSpPr>
-        <p:spPr>
-          <a:xfrm>
-            <a:off x="9275205" y="1654772"/>
-            <a:ext cx="438132" cy="1"/>
-          </a:xfrm>
-          <a:prstGeom prst="line">
-            <a:avLst/>
-          </a:prstGeom>
-          <a:ln>
-            <a:solidFill>
-              <a:srgbClr val="C00000"/>
-            </a:solidFill>
-          </a:ln>
-        </p:spPr>
-        <p:style>
-          <a:lnRef idx="1">
-            <a:schemeClr val="accent1"/>
-          </a:lnRef>
-          <a:fillRef idx="0">
-            <a:schemeClr val="accent1"/>
-          </a:fillRef>
-          <a:effectRef idx="0">
-            <a:schemeClr val="accent1"/>
-          </a:effectRef>
-          <a:fontRef idx="minor">
-            <a:schemeClr val="tx1"/>
-          </a:fontRef>
-        </p:style>
-      </p:cxnSp>
-      <p:sp>
-        <p:nvSpPr>
-          <p:cNvPr id="89" name="矩形 88"/>
-          <p:cNvSpPr/>
-          <p:nvPr/>
-        </p:nvSpPr>
-        <p:spPr>
-          <a:xfrm>
-            <a:off x="7973377" y="1825537"/>
-            <a:ext cx="156765" cy="203879"/>
-          </a:xfrm>
-          <a:prstGeom prst="rect">
-            <a:avLst/>
-          </a:prstGeom>
-          <a:solidFill>
-            <a:schemeClr val="bg1"/>
-          </a:solidFill>
-          <a:ln w="12700"/>
-        </p:spPr>
-        <p:style>
-          <a:lnRef idx="2">
-            <a:schemeClr val="accent1">
-              <a:shade val="50000"/>
-            </a:schemeClr>
-          </a:lnRef>
-          <a:fillRef idx="1">
-            <a:schemeClr val="accent1"/>
-          </a:fillRef>
-          <a:effectRef idx="0">
-            <a:schemeClr val="accent1"/>
-          </a:effectRef>
-          <a:fontRef idx="minor">
-            <a:schemeClr val="lt1"/>
-          </a:fontRef>
-        </p:style>
-        <p:txBody>
-          <a:bodyPr rtlCol="0" anchor="ctr"/>
-          <a:lstStyle/>
-          <a:p>
-            <a:pPr algn="ctr"/>
-            <a:endParaRPr lang="zh-CN" altLang="en-US"/>
-          </a:p>
-        </p:txBody>
-      </p:sp>
-      <p:cxnSp>
-        <p:nvCxnSpPr>
-          <p:cNvPr id="92" name="肘形连接符 91"/>
-          <p:cNvCxnSpPr>
-            <a:stCxn id="89" idx="0"/>
-            <a:endCxn id="106" idx="1"/>
-          </p:cNvCxnSpPr>
-          <p:nvPr/>
-        </p:nvCxnSpPr>
-        <p:spPr>
-          <a:xfrm rot="5400000" flipH="1" flipV="1">
-            <a:off x="8114040" y="1592493"/>
-            <a:ext cx="170765" cy="295324"/>
-          </a:xfrm>
-          <a:prstGeom prst="bentConnector2">
-            <a:avLst/>
-          </a:prstGeom>
-          <a:ln>
-            <a:solidFill>
-              <a:srgbClr val="C00000"/>
-            </a:solidFill>
-          </a:ln>
-        </p:spPr>
-        <p:style>
-          <a:lnRef idx="1">
-            <a:schemeClr val="accent1"/>
-          </a:lnRef>
-          <a:fillRef idx="0">
-            <a:schemeClr val="accent1"/>
-          </a:fillRef>
-          <a:effectRef idx="0">
-            <a:schemeClr val="accent1"/>
-          </a:effectRef>
-          <a:fontRef idx="minor">
-            <a:schemeClr val="tx1"/>
-          </a:fontRef>
-        </p:style>
-      </p:cxnSp>
-      <p:cxnSp>
-        <p:nvCxnSpPr>
-          <p:cNvPr id="4" name="直接箭头连接符 3"/>
-          <p:cNvCxnSpPr>
-            <a:stCxn id="28" idx="3"/>
-            <a:endCxn id="58" idx="1"/>
-          </p:cNvCxnSpPr>
-          <p:nvPr/>
-        </p:nvCxnSpPr>
-        <p:spPr>
-          <a:xfrm>
-            <a:off x="7752796" y="2684881"/>
-            <a:ext cx="119829" cy="3726"/>
-          </a:xfrm>
-          <a:prstGeom prst="straightConnector1">
-            <a:avLst/>
-          </a:prstGeom>
-          <a:ln>
-            <a:tailEnd type="arrow"/>
-          </a:ln>
-        </p:spPr>
-        <p:style>
-          <a:lnRef idx="1">
-            <a:schemeClr val="accent1"/>
-          </a:lnRef>
-          <a:fillRef idx="0">
-            <a:schemeClr val="accent1"/>
-          </a:fillRef>
-          <a:effectRef idx="0">
-            <a:schemeClr val="accent1"/>
-          </a:effectRef>
-          <a:fontRef idx="minor">
-            <a:schemeClr val="tx1"/>
-          </a:fontRef>
-        </p:style>
-      </p:cxnSp>
-      <p:sp>
-        <p:nvSpPr>
-          <p:cNvPr id="75" name="矩形 74"/>
-          <p:cNvSpPr/>
-          <p:nvPr/>
-        </p:nvSpPr>
-        <p:spPr>
-          <a:xfrm>
-            <a:off x="8063056" y="3591127"/>
-            <a:ext cx="1269574" cy="238014"/>
-          </a:xfrm>
-          <a:prstGeom prst="rect">
-            <a:avLst/>
-          </a:prstGeom>
-          <a:noFill/>
-          <a:ln w="12700"/>
-        </p:spPr>
-        <p:style>
-          <a:lnRef idx="2">
-            <a:schemeClr val="accent1">
-              <a:shade val="50000"/>
-            </a:schemeClr>
-          </a:lnRef>
-          <a:fillRef idx="1">
-            <a:schemeClr val="accent1"/>
-          </a:fillRef>
-          <a:effectRef idx="0">
-            <a:schemeClr val="accent1"/>
-          </a:effectRef>
-          <a:fontRef idx="minor">
-            <a:schemeClr val="lt1"/>
-          </a:fontRef>
-        </p:style>
-        <p:txBody>
-          <a:bodyPr rtlCol="0" anchor="ctr"/>
-          <a:lstStyle/>
-          <a:p>
-            <a:pPr algn="ctr"/>
-            <a:r>
-              <a:rPr lang="en-US" altLang="zh-CN" sz="1200" dirty="0">
-                <a:solidFill>
-                  <a:schemeClr val="tx1"/>
-                </a:solidFill>
-                <a:latin typeface="微软雅黑" panose="020B0503020204020204" pitchFamily="34" charset="-122"/>
-                <a:ea typeface="微软雅黑" panose="020B0503020204020204" pitchFamily="34" charset="-122"/>
-              </a:rPr>
-              <a:t>L298N</a:t>
-            </a:r>
-            <a:endParaRPr lang="zh-CN" altLang="en-US" sz="1200" dirty="0">
-              <a:solidFill>
-                <a:schemeClr val="tx1"/>
-              </a:solidFill>
-              <a:latin typeface="微软雅黑" panose="020B0503020204020204" pitchFamily="34" charset="-122"/>
-              <a:ea typeface="微软雅黑" panose="020B0503020204020204" pitchFamily="34" charset="-122"/>
-            </a:endParaRPr>
-          </a:p>
-        </p:txBody>
-      </p:sp>
-      <p:cxnSp>
-        <p:nvCxnSpPr>
-          <p:cNvPr id="47" name="直接连接符 46"/>
-          <p:cNvCxnSpPr>
-            <a:stCxn id="77" idx="2"/>
-            <a:endCxn id="75" idx="0"/>
-          </p:cNvCxnSpPr>
-          <p:nvPr/>
-        </p:nvCxnSpPr>
-        <p:spPr>
-          <a:xfrm flipH="1">
-            <a:off x="8697843" y="3356992"/>
-            <a:ext cx="1" cy="234135"/>
-          </a:xfrm>
-          <a:prstGeom prst="line">
-            <a:avLst/>
-          </a:prstGeom>
-          <a:ln>
-            <a:solidFill>
-              <a:srgbClr val="C00000"/>
-            </a:solidFill>
-          </a:ln>
-        </p:spPr>
-        <p:style>
-          <a:lnRef idx="1">
-            <a:schemeClr val="accent1"/>
-          </a:lnRef>
-          <a:fillRef idx="0">
-            <a:schemeClr val="accent1"/>
-          </a:fillRef>
-          <a:effectRef idx="0">
-            <a:schemeClr val="accent1"/>
-          </a:effectRef>
-          <a:fontRef idx="minor">
-            <a:schemeClr val="tx1"/>
-          </a:fontRef>
-        </p:style>
-      </p:cxnSp>
-      <p:cxnSp>
-        <p:nvCxnSpPr>
-          <p:cNvPr id="59" name="肘形连接符 58"/>
-          <p:cNvCxnSpPr>
-            <a:stCxn id="44" idx="3"/>
-            <a:endCxn id="28" idx="1"/>
-          </p:cNvCxnSpPr>
-          <p:nvPr/>
-        </p:nvCxnSpPr>
-        <p:spPr>
-          <a:xfrm>
-            <a:off x="6620445" y="2286029"/>
-            <a:ext cx="236671" cy="398852"/>
-          </a:xfrm>
-          <a:prstGeom prst="bentConnector3">
-            <a:avLst/>
-          </a:prstGeom>
-          <a:ln>
-            <a:tailEnd type="arrow"/>
-          </a:ln>
-        </p:spPr>
-        <p:style>
-          <a:lnRef idx="1">
-            <a:schemeClr val="accent1"/>
-          </a:lnRef>
-          <a:fillRef idx="0">
-            <a:schemeClr val="accent1"/>
-          </a:fillRef>
-          <a:effectRef idx="0">
-            <a:schemeClr val="accent1"/>
-          </a:effectRef>
-          <a:fontRef idx="minor">
-            <a:schemeClr val="tx1"/>
-          </a:fontRef>
-        </p:style>
-      </p:cxnSp>
-      <p:sp>
-        <p:nvSpPr>
-          <p:cNvPr id="61" name="TextBox 60"/>
-          <p:cNvSpPr txBox="1"/>
-          <p:nvPr/>
-        </p:nvSpPr>
-        <p:spPr>
-          <a:xfrm>
-            <a:off x="834730" y="1533467"/>
-            <a:ext cx="979627" cy="276999"/>
-          </a:xfrm>
-          <a:prstGeom prst="rect">
-            <a:avLst/>
-          </a:prstGeom>
-          <a:noFill/>
-        </p:spPr>
-        <p:txBody>
-          <a:bodyPr wrap="none" rtlCol="0">
-            <a:spAutoFit/>
-          </a:bodyPr>
-          <a:lstStyle/>
-          <a:p>
-            <a:r>
-              <a:rPr lang="en-US" altLang="zh-CN" sz="1200" dirty="0" smtClean="0"/>
-              <a:t>Phone/Pad…</a:t>
-            </a:r>
-            <a:endParaRPr lang="zh-CN" altLang="en-US" sz="1200" dirty="0"/>
-          </a:p>
-        </p:txBody>
-      </p:sp>
-      <p:sp>
-        <p:nvSpPr>
-          <p:cNvPr id="81" name="矩形 80"/>
-          <p:cNvSpPr/>
-          <p:nvPr/>
-        </p:nvSpPr>
-        <p:spPr>
-          <a:xfrm>
-            <a:off x="4286727" y="3309589"/>
-            <a:ext cx="397866" cy="200055"/>
-          </a:xfrm>
-          <a:prstGeom prst="rect">
-            <a:avLst/>
-          </a:prstGeom>
-        </p:spPr>
-        <p:txBody>
-          <a:bodyPr wrap="none">
-            <a:spAutoFit/>
-          </a:bodyPr>
-          <a:lstStyle/>
-          <a:p>
-            <a:r>
-              <a:rPr lang="en-US" altLang="zh-CN" sz="700" dirty="0"/>
-              <a:t>Radar</a:t>
-            </a:r>
-            <a:endParaRPr lang="zh-CN" altLang="en-US" sz="700" dirty="0"/>
-          </a:p>
-        </p:txBody>
-      </p:sp>
-      <p:pic>
-        <p:nvPicPr>
-          <p:cNvPr id="1026" name="Picture 2"/>
-          <p:cNvPicPr>
-            <a:picLocks noChangeAspect="1" noChangeArrowheads="1"/>
-          </p:cNvPicPr>
-          <p:nvPr/>
-        </p:nvPicPr>
-        <p:blipFill>
-          <a:blip r:embed="rId13" cstate="print">
-            <a:extLst>
-              <a:ext uri="{28A0092B-C50C-407E-A947-70E740481C1C}">
-                <a14:useLocalDpi xmlns:a14="http://schemas.microsoft.com/office/drawing/2010/main" val="0"/>
-              </a:ext>
-            </a:extLst>
-          </a:blip>
-          <a:srcRect/>
-          <a:stretch>
-            <a:fillRect/>
-          </a:stretch>
-        </p:blipFill>
-        <p:spPr bwMode="auto">
-          <a:xfrm>
-            <a:off x="936179" y="1844823"/>
-            <a:ext cx="2315828" cy="1281813"/>
-          </a:xfrm>
-          <a:prstGeom prst="rect">
-            <a:avLst/>
-          </a:prstGeom>
-          <a:noFill/>
-          <a:ln>
-            <a:noFill/>
-          </a:ln>
-          <a:effectLst/>
-          <a:extLst>
-            <a:ext uri="{909E8E84-426E-40DD-AFC4-6F175D3DCCD1}">
-              <a14:hiddenFill xmlns:a14="http://schemas.microsoft.com/office/drawing/2010/main">
-                <a:solidFill>
-                  <a:schemeClr val="accent1"/>
-                </a:solidFill>
-              </a14:hiddenFill>
-            </a:ext>
-            <a:ext uri="{91240B29-F687-4F45-9708-019B960494DF}">
-              <a14:hiddenLine xmlns:a14="http://schemas.microsoft.com/office/drawing/2010/main" w="9525">
-                <a:solidFill>
-                  <a:schemeClr val="tx1"/>
-                </a:solidFill>
-                <a:miter lim="800000"/>
-                <a:headEnd/>
-                <a:tailEnd/>
-              </a14:hiddenLine>
-            </a:ext>
-            <a:ext uri="{AF507438-7753-43E0-B8FC-AC1667EBCBE1}">
-              <a14:hiddenEffects xmlns:a14="http://schemas.microsoft.com/office/drawing/2010/main">
-                <a:effectLst>
-                  <a:outerShdw dist="35921" dir="2700000" algn="ctr" rotWithShape="0">
-                    <a:schemeClr val="bg2"/>
-                  </a:outerShdw>
-                </a:effectLst>
-              </a14:hiddenEffects>
-            </a:ext>
-          </a:extLst>
-        </p:spPr>
-      </p:pic>
-      <p:sp>
-        <p:nvSpPr>
           <p:cNvPr id="62" name="矩形 61"/>
           <p:cNvSpPr/>
           <p:nvPr/>
         </p:nvSpPr>
         <p:spPr>
           <a:xfrm>
-            <a:off x="8224245" y="2110552"/>
+            <a:off x="8619565" y="2392805"/>
             <a:ext cx="1310023" cy="230355"/>
           </a:xfrm>
           <a:prstGeom prst="rect">
@@ -5934,14 +5830,14 @@
               <a:t>Audio </a:t>
             </a:r>
             <a:r>
-              <a:rPr lang="en-US" altLang="zh-CN" sz="1050" dirty="0" err="1" smtClean="0">
+              <a:rPr lang="en-US" altLang="zh-CN" sz="1050" dirty="0" smtClean="0">
                 <a:solidFill>
                   <a:schemeClr val="tx1"/>
                 </a:solidFill>
                 <a:latin typeface="微软雅黑" panose="020B0503020204020204" pitchFamily="34" charset="-122"/>
                 <a:ea typeface="微软雅黑" panose="020B0503020204020204" pitchFamily="34" charset="-122"/>
               </a:rPr>
-              <a:t>Exeutor</a:t>
+              <a:t>Executor</a:t>
             </a:r>
             <a:endParaRPr lang="zh-CN" altLang="en-US" sz="1050" dirty="0">
               <a:solidFill>
@@ -5964,7 +5860,7 @@
         </p:nvCxnSpPr>
         <p:spPr>
           <a:xfrm rot="16200000" flipV="1">
-            <a:off x="8923340" y="2296825"/>
+            <a:off x="9318660" y="2579078"/>
             <a:ext cx="151989" cy="240154"/>
           </a:xfrm>
           <a:prstGeom prst="bentConnector3">
@@ -6000,7 +5896,7 @@
         </p:nvCxnSpPr>
         <p:spPr>
           <a:xfrm rot="10800000">
-            <a:off x="8051761" y="2029416"/>
+            <a:off x="8447081" y="2311669"/>
             <a:ext cx="172485" cy="196314"/>
           </a:xfrm>
           <a:prstGeom prst="bentConnector2">
@@ -6027,6 +5923,520 @@
           </a:fontRef>
         </p:style>
       </p:cxnSp>
+      <p:sp>
+        <p:nvSpPr>
+          <p:cNvPr id="63" name="矩形 62"/>
+          <p:cNvSpPr/>
+          <p:nvPr/>
+        </p:nvSpPr>
+        <p:spPr>
+          <a:xfrm>
+            <a:off x="1100893" y="2954583"/>
+            <a:ext cx="2322133" cy="1857420"/>
+          </a:xfrm>
+          <a:prstGeom prst="rect">
+            <a:avLst/>
+          </a:prstGeom>
+          <a:noFill/>
+          <a:ln w="12700"/>
+        </p:spPr>
+        <p:style>
+          <a:lnRef idx="2">
+            <a:schemeClr val="accent1">
+              <a:shade val="50000"/>
+            </a:schemeClr>
+          </a:lnRef>
+          <a:fillRef idx="1">
+            <a:schemeClr val="accent1"/>
+          </a:fillRef>
+          <a:effectRef idx="0">
+            <a:schemeClr val="accent1"/>
+          </a:effectRef>
+          <a:fontRef idx="minor">
+            <a:schemeClr val="lt1"/>
+          </a:fontRef>
+        </p:style>
+        <p:txBody>
+          <a:bodyPr rtlCol="0" anchor="t"/>
+          <a:lstStyle/>
+          <a:p>
+            <a:r>
+              <a:rPr lang="en-US" altLang="zh-CN" sz="1200" dirty="0">
+                <a:solidFill>
+                  <a:schemeClr val="tx1"/>
+                </a:solidFill>
+                <a:latin typeface="微软雅黑" panose="020B0503020204020204" pitchFamily="34" charset="-122"/>
+                <a:ea typeface="微软雅黑" panose="020B0503020204020204" pitchFamily="34" charset="-122"/>
+              </a:rPr>
+              <a:t>Center </a:t>
+            </a:r>
+            <a:r>
+              <a:rPr lang="en-US" altLang="zh-CN" sz="1200" dirty="0" smtClean="0">
+                <a:solidFill>
+                  <a:schemeClr val="tx1"/>
+                </a:solidFill>
+                <a:latin typeface="微软雅黑" panose="020B0503020204020204" pitchFamily="34" charset="-122"/>
+                <a:ea typeface="微软雅黑" panose="020B0503020204020204" pitchFamily="34" charset="-122"/>
+              </a:rPr>
+              <a:t>Server</a:t>
+            </a:r>
+            <a:endParaRPr lang="zh-CN" altLang="en-US" sz="1200" dirty="0">
+              <a:solidFill>
+                <a:schemeClr val="tx1"/>
+              </a:solidFill>
+              <a:latin typeface="微软雅黑" panose="020B0503020204020204" pitchFamily="34" charset="-122"/>
+              <a:ea typeface="微软雅黑" panose="020B0503020204020204" pitchFamily="34" charset="-122"/>
+            </a:endParaRPr>
+          </a:p>
+        </p:txBody>
+      </p:sp>
+      <p:pic>
+        <p:nvPicPr>
+          <p:cNvPr id="64" name="Picture 15"/>
+          <p:cNvPicPr>
+            <a:picLocks noChangeAspect="1" noChangeArrowheads="1"/>
+          </p:cNvPicPr>
+          <p:nvPr/>
+        </p:nvPicPr>
+        <p:blipFill>
+          <a:blip r:embed="rId6" cstate="print">
+            <a:extLst>
+              <a:ext uri="{28A0092B-C50C-407E-A947-70E740481C1C}">
+                <a14:useLocalDpi xmlns:a14="http://schemas.microsoft.com/office/drawing/2010/main" val="0"/>
+              </a:ext>
+            </a:extLst>
+          </a:blip>
+          <a:srcRect/>
+          <a:stretch>
+            <a:fillRect/>
+          </a:stretch>
+        </p:blipFill>
+        <p:spPr bwMode="auto">
+          <a:xfrm>
+            <a:off x="1472000" y="3260512"/>
+            <a:ext cx="493723" cy="407038"/>
+          </a:xfrm>
+          <a:prstGeom prst="rect">
+            <a:avLst/>
+          </a:prstGeom>
+          <a:noFill/>
+          <a:ln>
+            <a:noFill/>
+          </a:ln>
+          <a:effectLst/>
+          <a:extLst>
+            <a:ext uri="{909E8E84-426E-40DD-AFC4-6F175D3DCCD1}">
+              <a14:hiddenFill xmlns:a14="http://schemas.microsoft.com/office/drawing/2010/main">
+                <a:solidFill>
+                  <a:schemeClr val="accent1"/>
+                </a:solidFill>
+              </a14:hiddenFill>
+            </a:ext>
+            <a:ext uri="{91240B29-F687-4F45-9708-019B960494DF}">
+              <a14:hiddenLine xmlns:a14="http://schemas.microsoft.com/office/drawing/2010/main" w="9525">
+                <a:solidFill>
+                  <a:schemeClr val="tx1"/>
+                </a:solidFill>
+                <a:miter lim="800000"/>
+                <a:headEnd/>
+                <a:tailEnd/>
+              </a14:hiddenLine>
+            </a:ext>
+            <a:ext uri="{AF507438-7753-43E0-B8FC-AC1667EBCBE1}">
+              <a14:hiddenEffects xmlns:a14="http://schemas.microsoft.com/office/drawing/2010/main">
+                <a:effectLst>
+                  <a:outerShdw dist="35921" dir="2700000" algn="ctr" rotWithShape="0">
+                    <a:schemeClr val="bg2"/>
+                  </a:outerShdw>
+                </a:effectLst>
+              </a14:hiddenEffects>
+            </a:ext>
+          </a:extLst>
+        </p:spPr>
+      </p:pic>
+      <p:sp>
+        <p:nvSpPr>
+          <p:cNvPr id="65" name="矩形 64"/>
+          <p:cNvSpPr/>
+          <p:nvPr/>
+        </p:nvSpPr>
+        <p:spPr>
+          <a:xfrm>
+            <a:off x="1374809" y="3863715"/>
+            <a:ext cx="1760185" cy="238014"/>
+          </a:xfrm>
+          <a:prstGeom prst="rect">
+            <a:avLst/>
+          </a:prstGeom>
+          <a:noFill/>
+          <a:ln w="6350">
+            <a:solidFill>
+              <a:schemeClr val="accent3">
+                <a:lumMod val="40000"/>
+                <a:lumOff val="60000"/>
+              </a:schemeClr>
+            </a:solidFill>
+          </a:ln>
+        </p:spPr>
+        <p:style>
+          <a:lnRef idx="2">
+            <a:schemeClr val="accent1">
+              <a:shade val="50000"/>
+            </a:schemeClr>
+          </a:lnRef>
+          <a:fillRef idx="1">
+            <a:schemeClr val="accent1"/>
+          </a:fillRef>
+          <a:effectRef idx="0">
+            <a:schemeClr val="accent1"/>
+          </a:effectRef>
+          <a:fontRef idx="minor">
+            <a:schemeClr val="lt1"/>
+          </a:fontRef>
+        </p:style>
+        <p:txBody>
+          <a:bodyPr rtlCol="0" anchor="ctr"/>
+          <a:lstStyle/>
+          <a:p>
+            <a:pPr algn="ctr"/>
+            <a:r>
+              <a:rPr lang="en-US" altLang="zh-CN" sz="1100" dirty="0" smtClean="0">
+                <a:solidFill>
+                  <a:schemeClr val="tx1"/>
+                </a:solidFill>
+                <a:latin typeface="微软雅黑" panose="020B0503020204020204" pitchFamily="34" charset="-122"/>
+                <a:ea typeface="微软雅黑" panose="020B0503020204020204" pitchFamily="34" charset="-122"/>
+              </a:rPr>
+              <a:t>Gateway</a:t>
+            </a:r>
+            <a:endParaRPr lang="zh-CN" altLang="en-US" sz="1100" dirty="0">
+              <a:solidFill>
+                <a:schemeClr val="tx1"/>
+              </a:solidFill>
+              <a:latin typeface="微软雅黑" panose="020B0503020204020204" pitchFamily="34" charset="-122"/>
+              <a:ea typeface="微软雅黑" panose="020B0503020204020204" pitchFamily="34" charset="-122"/>
+            </a:endParaRPr>
+          </a:p>
+        </p:txBody>
+      </p:sp>
+      <p:sp>
+        <p:nvSpPr>
+          <p:cNvPr id="67" name="矩形 66"/>
+          <p:cNvSpPr/>
+          <p:nvPr/>
+        </p:nvSpPr>
+        <p:spPr>
+          <a:xfrm>
+            <a:off x="1374809" y="4154766"/>
+            <a:ext cx="1760185" cy="238014"/>
+          </a:xfrm>
+          <a:prstGeom prst="rect">
+            <a:avLst/>
+          </a:prstGeom>
+          <a:noFill/>
+          <a:ln w="6350">
+            <a:solidFill>
+              <a:schemeClr val="accent3">
+                <a:lumMod val="40000"/>
+                <a:lumOff val="60000"/>
+              </a:schemeClr>
+            </a:solidFill>
+          </a:ln>
+        </p:spPr>
+        <p:style>
+          <a:lnRef idx="2">
+            <a:schemeClr val="accent1">
+              <a:shade val="50000"/>
+            </a:schemeClr>
+          </a:lnRef>
+          <a:fillRef idx="1">
+            <a:schemeClr val="accent1"/>
+          </a:fillRef>
+          <a:effectRef idx="0">
+            <a:schemeClr val="accent1"/>
+          </a:effectRef>
+          <a:fontRef idx="minor">
+            <a:schemeClr val="lt1"/>
+          </a:fontRef>
+        </p:style>
+        <p:txBody>
+          <a:bodyPr rtlCol="0" anchor="ctr"/>
+          <a:lstStyle/>
+          <a:p>
+            <a:pPr algn="ctr"/>
+            <a:r>
+              <a:rPr lang="en-US" altLang="zh-CN" sz="1050" dirty="0" smtClean="0">
+                <a:solidFill>
+                  <a:schemeClr val="tx1"/>
+                </a:solidFill>
+                <a:latin typeface="微软雅黑" panose="020B0503020204020204" pitchFamily="34" charset="-122"/>
+                <a:ea typeface="微软雅黑" panose="020B0503020204020204" pitchFamily="34" charset="-122"/>
+              </a:rPr>
+              <a:t>VLA Infer</a:t>
+            </a:r>
+            <a:endParaRPr lang="zh-CN" altLang="en-US" sz="1050" dirty="0">
+              <a:solidFill>
+                <a:schemeClr val="tx1"/>
+              </a:solidFill>
+              <a:latin typeface="微软雅黑" panose="020B0503020204020204" pitchFamily="34" charset="-122"/>
+              <a:ea typeface="微软雅黑" panose="020B0503020204020204" pitchFamily="34" charset="-122"/>
+            </a:endParaRPr>
+          </a:p>
+        </p:txBody>
+      </p:sp>
+      <p:sp>
+        <p:nvSpPr>
+          <p:cNvPr id="70" name="矩形 69"/>
+          <p:cNvSpPr/>
+          <p:nvPr/>
+        </p:nvSpPr>
+        <p:spPr>
+          <a:xfrm>
+            <a:off x="1374809" y="4453686"/>
+            <a:ext cx="1760185" cy="238014"/>
+          </a:xfrm>
+          <a:prstGeom prst="rect">
+            <a:avLst/>
+          </a:prstGeom>
+          <a:noFill/>
+          <a:ln w="6350">
+            <a:solidFill>
+              <a:schemeClr val="accent3">
+                <a:lumMod val="40000"/>
+                <a:lumOff val="60000"/>
+              </a:schemeClr>
+            </a:solidFill>
+          </a:ln>
+        </p:spPr>
+        <p:style>
+          <a:lnRef idx="2">
+            <a:schemeClr val="accent1">
+              <a:shade val="50000"/>
+            </a:schemeClr>
+          </a:lnRef>
+          <a:fillRef idx="1">
+            <a:schemeClr val="accent1"/>
+          </a:fillRef>
+          <a:effectRef idx="0">
+            <a:schemeClr val="accent1"/>
+          </a:effectRef>
+          <a:fontRef idx="minor">
+            <a:schemeClr val="lt1"/>
+          </a:fontRef>
+        </p:style>
+        <p:txBody>
+          <a:bodyPr rtlCol="0" anchor="ctr"/>
+          <a:lstStyle/>
+          <a:p>
+            <a:pPr algn="ctr"/>
+            <a:r>
+              <a:rPr lang="en-US" altLang="zh-CN" sz="1100" dirty="0" smtClean="0">
+                <a:solidFill>
+                  <a:schemeClr val="tx1"/>
+                </a:solidFill>
+                <a:latin typeface="微软雅黑" panose="020B0503020204020204" pitchFamily="34" charset="-122"/>
+                <a:ea typeface="微软雅黑" panose="020B0503020204020204" pitchFamily="34" charset="-122"/>
+              </a:rPr>
+              <a:t>ROS2 Platform</a:t>
+            </a:r>
+            <a:endParaRPr lang="zh-CN" altLang="en-US" sz="1100" dirty="0">
+              <a:solidFill>
+                <a:schemeClr val="tx1"/>
+              </a:solidFill>
+              <a:latin typeface="微软雅黑" panose="020B0503020204020204" pitchFamily="34" charset="-122"/>
+              <a:ea typeface="微软雅黑" panose="020B0503020204020204" pitchFamily="34" charset="-122"/>
+            </a:endParaRPr>
+          </a:p>
+        </p:txBody>
+      </p:sp>
+      <p:pic>
+        <p:nvPicPr>
+          <p:cNvPr id="72" name="Picture 17"/>
+          <p:cNvPicPr>
+            <a:picLocks noChangeAspect="1" noChangeArrowheads="1"/>
+          </p:cNvPicPr>
+          <p:nvPr/>
+        </p:nvPicPr>
+        <p:blipFill>
+          <a:blip r:embed="rId13">
+            <a:extLst>
+              <a:ext uri="{28A0092B-C50C-407E-A947-70E740481C1C}">
+                <a14:useLocalDpi xmlns:a14="http://schemas.microsoft.com/office/drawing/2010/main" val="0"/>
+              </a:ext>
+            </a:extLst>
+          </a:blip>
+          <a:srcRect/>
+          <a:stretch>
+            <a:fillRect/>
+          </a:stretch>
+        </p:blipFill>
+        <p:spPr bwMode="auto">
+          <a:xfrm>
+            <a:off x="2414915" y="3260511"/>
+            <a:ext cx="448531" cy="407039"/>
+          </a:xfrm>
+          <a:prstGeom prst="rect">
+            <a:avLst/>
+          </a:prstGeom>
+          <a:noFill/>
+          <a:ln>
+            <a:noFill/>
+          </a:ln>
+          <a:effectLst/>
+          <a:extLst>
+            <a:ext uri="{909E8E84-426E-40DD-AFC4-6F175D3DCCD1}">
+              <a14:hiddenFill xmlns:a14="http://schemas.microsoft.com/office/drawing/2010/main">
+                <a:solidFill>
+                  <a:schemeClr val="accent1"/>
+                </a:solidFill>
+              </a14:hiddenFill>
+            </a:ext>
+            <a:ext uri="{91240B29-F687-4F45-9708-019B960494DF}">
+              <a14:hiddenLine xmlns:a14="http://schemas.microsoft.com/office/drawing/2010/main" w="9525">
+                <a:solidFill>
+                  <a:schemeClr val="tx1"/>
+                </a:solidFill>
+                <a:miter lim="800000"/>
+                <a:headEnd/>
+                <a:tailEnd/>
+              </a14:hiddenLine>
+            </a:ext>
+            <a:ext uri="{AF507438-7753-43E0-B8FC-AC1667EBCBE1}">
+              <a14:hiddenEffects xmlns:a14="http://schemas.microsoft.com/office/drawing/2010/main">
+                <a:effectLst>
+                  <a:outerShdw dist="35921" dir="2700000" algn="ctr" rotWithShape="0">
+                    <a:schemeClr val="bg2"/>
+                  </a:outerShdw>
+                </a:effectLst>
+              </a14:hiddenEffects>
+            </a:ext>
+          </a:extLst>
+        </p:spPr>
+      </p:pic>
+      <p:sp>
+        <p:nvSpPr>
+          <p:cNvPr id="73" name="TextBox 72"/>
+          <p:cNvSpPr txBox="1"/>
+          <p:nvPr/>
+        </p:nvSpPr>
+        <p:spPr>
+          <a:xfrm>
+            <a:off x="1512243" y="3617494"/>
+            <a:ext cx="349851" cy="246221"/>
+          </a:xfrm>
+          <a:prstGeom prst="rect">
+            <a:avLst/>
+          </a:prstGeom>
+          <a:noFill/>
+        </p:spPr>
+        <p:txBody>
+          <a:bodyPr wrap="none" rtlCol="0">
+            <a:spAutoFit/>
+          </a:bodyPr>
+          <a:lstStyle/>
+          <a:p>
+            <a:r>
+              <a:rPr lang="en-US" altLang="zh-CN" sz="1000" dirty="0" smtClean="0"/>
+              <a:t>WIFI</a:t>
+            </a:r>
+            <a:endParaRPr lang="zh-CN" altLang="en-US" sz="1000" dirty="0"/>
+          </a:p>
+        </p:txBody>
+      </p:sp>
+      <p:sp>
+        <p:nvSpPr>
+          <p:cNvPr id="74" name="TextBox 73"/>
+          <p:cNvSpPr txBox="1"/>
+          <p:nvPr/>
+        </p:nvSpPr>
+        <p:spPr>
+          <a:xfrm>
+            <a:off x="2459934" y="3617494"/>
+            <a:ext cx="319280" cy="246221"/>
+          </a:xfrm>
+          <a:prstGeom prst="rect">
+            <a:avLst/>
+          </a:prstGeom>
+          <a:noFill/>
+        </p:spPr>
+        <p:txBody>
+          <a:bodyPr wrap="none" rtlCol="0">
+            <a:spAutoFit/>
+          </a:bodyPr>
+          <a:lstStyle/>
+          <a:p>
+            <a:r>
+              <a:rPr lang="en-US" altLang="zh-CN" sz="1000" dirty="0" smtClean="0"/>
+              <a:t>VLA</a:t>
+            </a:r>
+            <a:endParaRPr lang="zh-CN" altLang="en-US" sz="1000" dirty="0"/>
+          </a:p>
+        </p:txBody>
+      </p:sp>
+      <p:pic>
+        <p:nvPicPr>
+          <p:cNvPr id="1027" name="Picture 3"/>
+          <p:cNvPicPr>
+            <a:picLocks noChangeAspect="1" noChangeArrowheads="1"/>
+          </p:cNvPicPr>
+          <p:nvPr/>
+        </p:nvPicPr>
+        <p:blipFill>
+          <a:blip r:embed="rId14">
+            <a:extLst>
+              <a:ext uri="{28A0092B-C50C-407E-A947-70E740481C1C}">
+                <a14:useLocalDpi xmlns:a14="http://schemas.microsoft.com/office/drawing/2010/main" val="0"/>
+              </a:ext>
+            </a:extLst>
+          </a:blip>
+          <a:srcRect/>
+          <a:stretch>
+            <a:fillRect/>
+          </a:stretch>
+        </p:blipFill>
+        <p:spPr bwMode="auto">
+          <a:xfrm>
+            <a:off x="5832409" y="2507983"/>
+            <a:ext cx="494999" cy="407039"/>
+          </a:xfrm>
+          <a:prstGeom prst="rect">
+            <a:avLst/>
+          </a:prstGeom>
+          <a:noFill/>
+          <a:ln>
+            <a:noFill/>
+          </a:ln>
+          <a:effectLst/>
+          <a:extLst>
+            <a:ext uri="{909E8E84-426E-40DD-AFC4-6F175D3DCCD1}">
+              <a14:hiddenFill xmlns:a14="http://schemas.microsoft.com/office/drawing/2010/main">
+                <a:solidFill>
+                  <a:schemeClr val="accent1"/>
+                </a:solidFill>
+              </a14:hiddenFill>
+            </a:ext>
+            <a:ext uri="{91240B29-F687-4F45-9708-019B960494DF}">
+              <a14:hiddenLine xmlns:a14="http://schemas.microsoft.com/office/drawing/2010/main" w="9525">
+                <a:solidFill>
+                  <a:schemeClr val="tx1"/>
+                </a:solidFill>
+                <a:miter lim="800000"/>
+                <a:headEnd/>
+                <a:tailEnd/>
+              </a14:hiddenLine>
+            </a:ext>
+            <a:ext uri="{AF507438-7753-43E0-B8FC-AC1667EBCBE1}">
+              <a14:hiddenEffects xmlns:a14="http://schemas.microsoft.com/office/drawing/2010/main">
+                <a:effectLst>
+                  <a:outerShdw dist="35921" dir="2700000" algn="ctr" rotWithShape="0">
+                    <a:schemeClr val="bg2"/>
+                  </a:outerShdw>
+                </a:effectLst>
+              </a14:hiddenEffects>
+            </a:ext>
+          </a:extLst>
+        </p:spPr>
+      </p:pic>
     </p:spTree>
     <p:extLst>
       <p:ext uri="{BB962C8B-B14F-4D97-AF65-F5344CB8AC3E}">

</xml_diff>

<commit_message>
change remote to edge server.
</commit_message>
<xml_diff>
--- a/images/arch.pptx
+++ b/images/arch.pptx
@@ -3473,7 +3473,17 @@
                 <a:latin typeface="微软雅黑" panose="020B0503020204020204" pitchFamily="34" charset="-122"/>
                 <a:ea typeface="微软雅黑" panose="020B0503020204020204" pitchFamily="34" charset="-122"/>
               </a:rPr>
-              <a:t>In-vehicle System</a:t>
+              <a:t>In-vehicle </a:t>
+            </a:r>
+            <a:r>
+              <a:rPr lang="en-US" altLang="zh-CN" dirty="0" smtClean="0">
+                <a:solidFill>
+                  <a:schemeClr val="tx1"/>
+                </a:solidFill>
+                <a:latin typeface="微软雅黑" panose="020B0503020204020204" pitchFamily="34" charset="-122"/>
+                <a:ea typeface="微软雅黑" panose="020B0503020204020204" pitchFamily="34" charset="-122"/>
+              </a:rPr>
+              <a:t>System(Edge Server)</a:t>
             </a:r>
             <a:endParaRPr lang="zh-CN" altLang="en-US" dirty="0">
               <a:solidFill>

</xml_diff>